<commit_message>
docs: require real v6 runtime comparison evidence
</commit_message>
<xml_diff>
--- a/presentation/PGRR_report_zh.pptx
+++ b/presentation/PGRR_report_zh.pptx
@@ -3156,7 +3156,7 @@
               </a:defRPr>
             </a:pPr>
             <a:r>
-              <a:t>规划引导、失败触发的动态社会导航恢复与重接</a:t>
+              <a:t>PGRR：规划引导、失败触发的动态社会导航恢复与重接</a:t>
             </a:r>
           </a:p>
         </p:txBody>
@@ -3192,7 +3192,7 @@
               </a:defRPr>
             </a:pPr>
             <a:r>
-              <a:t>PGRR：让经典规划器保持常态控制，只在可观测失败前兆持续时介入</a:t>
+              <a:t>PGRR: Planning-Guided Failure-Triggered Recovery and Rejoin for Dynamic Social Navigation</a:t>
             </a:r>
           </a:p>
         </p:txBody>
@@ -5491,7 +5491,7 @@
               </a:defRPr>
             </a:pPr>
             <a:r>
-              <a:t>• 场景：doorway_bottleneck / medium / validation</a:t>
+              <a:t>• 环境：Ubuntu 22.04 / ROS2 Humble / Arena Gazebo</a:t>
             </a:r>
           </a:p>
           <a:p>
@@ -5507,7 +5507,7 @@
               </a:defRPr>
             </a:pPr>
             <a:r>
-              <a:t>• 规划器：Nav2 DWB；仿真器：Gazebo</a:t>
+              <a:t>• 机器人与感知：Jackal / Nav2 DWB / 平面 LiDAR</a:t>
             </a:r>
           </a:p>
           <a:p>
@@ -5523,7 +5523,7 @@
               </a:defRPr>
             </a:pPr>
             <a:r>
-              <a:t>• 关联 episode 结局：GOAL_REACHED</a:t>
+              <a:t>• 冻结 v5 演示：doorway_bottleneck / medium / validation</a:t>
             </a:r>
           </a:p>
           <a:p>
@@ -5555,7 +5555,7 @@
               </a:defRPr>
             </a:pPr>
             <a:r>
-              <a:t>• 该截图只作运行证明，不替代完整定量实验</a:t>
+              <a:t>• 它不是锁定 v6 统计回合的 camera frame，也不替代定量实验</a:t>
             </a:r>
           </a:p>
         </p:txBody>
@@ -6155,7 +6155,23 @@
               </a:defRPr>
             </a:pPr>
             <a:r>
-              <a:t>• Train / validation / test 使用不相交 seed 和 scenario ID</a:t>
+              <a:t>• moderate-v6：Train / validation / test 使用不相交 seed 和 scenario ID</a:t>
+            </a:r>
+          </a:p>
+          <a:p>
+            <a:pPr>
+              <a:spcAft>
+                <a:spcPts val="800"/>
+              </a:spcAft>
+              <a:defRPr sz="1900">
+                <a:solidFill>
+                  <a:srgbClr val="1B1F23"/>
+                </a:solidFill>
+                <a:latin typeface="Noto Sans CJK SC"/>
+              </a:defRPr>
+            </a:pPr>
+            <a:r>
+              <a:t>• v5 Base validation 57/72，超过 75% ceiling，故 rejected 且 test 未打开</a:t>
             </a:r>
           </a:p>
           <a:p>
@@ -8785,7 +8801,7 @@
               </a:defRPr>
             </a:pPr>
             <a:r>
-              <a:t>恢复行为审计</a:t>
+              <a:t>Matched Base--PGRR 真实运行对比</a:t>
             </a:r>
           </a:p>
         </p:txBody>
@@ -8864,7 +8880,7 @@
               </a:defRPr>
             </a:pPr>
             <a:r>
-              <a:t>恢复行为要检查 WAIT/BACKUP 滥用和过度介入</a:t>
+              <a:t>matched 运行页等待 hash-linked raw/Parquet sidecar</a:t>
             </a:r>
           </a:p>
         </p:txBody>
@@ -8919,7 +8935,7 @@
               </a:defRPr>
             </a:pPr>
             <a:r>
-              <a:t>• 本页计划展示：触发、重接成功、恢复时长和介入比例</a:t>
+              <a:t>• 本页计划展示：预注册 doorway/medium/r00 的 Base--PGRR 空间轨迹与事件时间线；遥测重建，不是 camera screenshot</a:t>
             </a:r>
           </a:p>
           <a:p>
@@ -9551,7 +9567,7 @@
               </a:defRPr>
             </a:pPr>
             <a:r>
-              <a:t>• 没有形式化安全保证，也没有实机泛化结论</a:t>
+              <a:t>• PPO、学习 detector、第二 planner、Flatland、硬件和形式安全均未完成</a:t>
             </a:r>
           </a:p>
         </p:txBody>
@@ -11487,7 +11503,7 @@
               </a:defRPr>
             </a:pPr>
             <a:r>
-              <a:t>• 不声称首次结合、不声称无碰撞保证、不把 PPO 写成完成贡献</a:t>
+              <a:t>• PPO、学习 detector、第二 planner、Flatland、硬件与形式安全均非完成声明</a:t>
             </a:r>
           </a:p>
         </p:txBody>

</xml_diff>

<commit_message>
report: gate final materials on real matched evidence
</commit_message>
<xml_diff>
--- a/presentation/PGRR_report_zh.pptx
+++ b/presentation/PGRR_report_zh.pptx
@@ -5539,7 +5539,7 @@
               </a:defRPr>
             </a:pPr>
             <a:r>
-              <a:t>• 截图、窗口、日志、commit 与 SHA256 均有元数据</a:t>
+              <a:t>• episode ID：runtime_capture_gazebo_doorway_bottleneck_medium_20260806T054015Z_3875172；pixel SHA256：5313957c3032</a:t>
             </a:r>
           </a:p>
           <a:p>
@@ -6854,6 +6854,22 @@
               <a:t>• 完成后恢复原始 PointGoal 并重新接回经典导航</a:t>
             </a:r>
           </a:p>
+          <a:p>
+            <a:pPr>
+              <a:spcAft>
+                <a:spcPts val="800"/>
+              </a:spcAft>
+              <a:defRPr sz="1900">
+                <a:solidFill>
+                  <a:srgbClr val="1B1F23"/>
+                </a:solidFill>
+                <a:latin typeface="Noto Sans CJK SC"/>
+              </a:defRPr>
+            </a:pPr>
+            <a:r>
+              <a:t>• 历史 v1 64/64（非 v6）：PGRR/Base 碰撞 0/24 vs 19/24、超时 16/24 vs 0/24、到达 8/24 vs 5/24；校正成功差异不显著</a:t>
+            </a:r>
+          </a:p>
         </p:txBody>
       </p:sp>
       <p:sp>
@@ -9101,7 +9117,7 @@
               </a:defRPr>
             </a:pPr>
             <a:r>
-              <a:t>训练与消融</a:t>
+              <a:t>PGRR 恢复时序（同一 Matched Pair）</a:t>
             </a:r>
           </a:p>
         </p:txBody>
@@ -9180,7 +9196,7 @@
               </a:defRPr>
             </a:pPr>
             <a:r>
-              <a:t>离线准确率不能替代闭环导航证据</a:t>
+              <a:t>恢复时序素材与轨迹素材必须来自同一 test pair</a:t>
             </a:r>
           </a:p>
         </p:txBody>
@@ -9235,7 +9251,7 @@
               </a:defRPr>
             </a:pPr>
             <a:r>
-              <a:t>• 本页计划展示：BC、DAgger、mask 与 checkpoint 选择消融</a:t>
+              <a:t>• 本页计划展示：固定文件名的 PGRR 目标距离、failure score、恢复状态与触发时间线；遥测重建，不是 camera screenshot</a:t>
             </a:r>
           </a:p>
           <a:p>
@@ -9552,6 +9568,22 @@
             </a:pPr>
             <a:r>
               <a:t>• 二维 LiDAR、已知地图、离散动作和仿真人群限制外推</a:t>
+            </a:r>
+          </a:p>
+          <a:p>
+            <a:pPr>
+              <a:spcAft>
+                <a:spcPts val="800"/>
+              </a:spcAft>
+              <a:defRPr sz="1650">
+                <a:solidFill>
+                  <a:srgbClr val="1B1F23"/>
+                </a:solidFill>
+                <a:latin typeface="Noto Sans CJK SC"/>
+              </a:defRPr>
+            </a:pPr>
+            <a:r>
+              <a:t>• 历史 v1 64/64（非 v6）显示碰撞下降伴随 timeout 上升；到达 8/24 vs 5/24 的校正比较不显著</a:t>
             </a:r>
           </a:p>
           <a:p>

</xml_diff>

<commit_message>
release: publish moderate-v6 held-out evidence
</commit_message>
<xml_diff>
--- a/presentation/PGRR_report_zh.pptx
+++ b/presentation/PGRR_report_zh.pptx
@@ -3271,7 +3271,7 @@
               </a:defRPr>
             </a:pPr>
             <a:r>
-              <a:t>• 验证执行中｜数值待锁定</a:t>
+              <a:t>• 锁定 Test 结果</a:t>
             </a:r>
           </a:p>
           <a:p>
@@ -3317,13 +3317,13 @@
             <a:pPr>
               <a:defRPr sz="950" b="0">
                 <a:solidFill>
-                  <a:srgbClr val="D55E00"/>
-                </a:solidFill>
-                <a:latin typeface="Noto Sans CJK SC"/>
-              </a:defRPr>
-            </a:pPr>
-            <a:r>
-              <a:t>验证执行中｜结果待锁定</a:t>
+                  <a:srgbClr val="356E9F"/>
+                </a:solidFill>
+                <a:latin typeface="Noto Sans CJK SC"/>
+              </a:defRPr>
+            </a:pPr>
+            <a:r>
+              <a:t>锁定 Test 结果</a:t>
             </a:r>
           </a:p>
         </p:txBody>
@@ -3633,13 +3633,13 @@
             <a:pPr>
               <a:defRPr sz="950" b="0">
                 <a:solidFill>
-                  <a:srgbClr val="D55E00"/>
-                </a:solidFill>
-                <a:latin typeface="Noto Sans CJK SC"/>
-              </a:defRPr>
-            </a:pPr>
-            <a:r>
-              <a:t>验证执行中｜结果待锁定</a:t>
+                  <a:srgbClr val="356E9F"/>
+                </a:solidFill>
+                <a:latin typeface="Noto Sans CJK SC"/>
+              </a:defRPr>
+            </a:pPr>
+            <a:r>
+              <a:t>锁定 Test 结果</a:t>
             </a:r>
           </a:p>
         </p:txBody>
@@ -3949,13 +3949,13 @@
             <a:pPr>
               <a:defRPr sz="950" b="0">
                 <a:solidFill>
-                  <a:srgbClr val="D55E00"/>
-                </a:solidFill>
-                <a:latin typeface="Noto Sans CJK SC"/>
-              </a:defRPr>
-            </a:pPr>
-            <a:r>
-              <a:t>验证执行中｜结果待锁定</a:t>
+                  <a:srgbClr val="356E9F"/>
+                </a:solidFill>
+                <a:latin typeface="Noto Sans CJK SC"/>
+              </a:defRPr>
+            </a:pPr>
+            <a:r>
+              <a:t>锁定 Test 结果</a:t>
             </a:r>
           </a:p>
         </p:txBody>
@@ -4289,13 +4289,13 @@
             <a:pPr>
               <a:defRPr sz="950" b="0">
                 <a:solidFill>
-                  <a:srgbClr val="D55E00"/>
-                </a:solidFill>
-                <a:latin typeface="Noto Sans CJK SC"/>
-              </a:defRPr>
-            </a:pPr>
-            <a:r>
-              <a:t>验证执行中｜结果待锁定</a:t>
+                  <a:srgbClr val="356E9F"/>
+                </a:solidFill>
+                <a:latin typeface="Noto Sans CJK SC"/>
+              </a:defRPr>
+            </a:pPr>
+            <a:r>
+              <a:t>锁定 Test 结果</a:t>
             </a:r>
           </a:p>
         </p:txBody>
@@ -4629,13 +4629,13 @@
             <a:pPr>
               <a:defRPr sz="950" b="0">
                 <a:solidFill>
-                  <a:srgbClr val="D55E00"/>
-                </a:solidFill>
-                <a:latin typeface="Noto Sans CJK SC"/>
-              </a:defRPr>
-            </a:pPr>
-            <a:r>
-              <a:t>验证执行中｜结果待锁定</a:t>
+                  <a:srgbClr val="356E9F"/>
+                </a:solidFill>
+                <a:latin typeface="Noto Sans CJK SC"/>
+              </a:defRPr>
+            </a:pPr>
+            <a:r>
+              <a:t>锁定 Test 结果</a:t>
             </a:r>
           </a:p>
         </p:txBody>
@@ -4945,13 +4945,13 @@
             <a:pPr>
               <a:defRPr sz="950" b="0">
                 <a:solidFill>
-                  <a:srgbClr val="D55E00"/>
-                </a:solidFill>
-                <a:latin typeface="Noto Sans CJK SC"/>
-              </a:defRPr>
-            </a:pPr>
-            <a:r>
-              <a:t>验证执行中｜结果待锁定</a:t>
+                  <a:srgbClr val="356E9F"/>
+                </a:solidFill>
+                <a:latin typeface="Noto Sans CJK SC"/>
+              </a:defRPr>
+            </a:pPr>
+            <a:r>
+              <a:t>锁定 Test 结果</a:t>
             </a:r>
           </a:p>
         </p:txBody>
@@ -5269,13 +5269,13 @@
             <a:pPr>
               <a:defRPr sz="950" b="0">
                 <a:solidFill>
-                  <a:srgbClr val="D55E00"/>
-                </a:solidFill>
-                <a:latin typeface="Noto Sans CJK SC"/>
-              </a:defRPr>
-            </a:pPr>
-            <a:r>
-              <a:t>验证执行中｜结果待锁定</a:t>
+                  <a:srgbClr val="356E9F"/>
+                </a:solidFill>
+                <a:latin typeface="Noto Sans CJK SC"/>
+              </a:defRPr>
+            </a:pPr>
+            <a:r>
+              <a:t>锁定 Test 结果</a:t>
             </a:r>
           </a:p>
         </p:txBody>
@@ -5609,13 +5609,13 @@
             <a:pPr>
               <a:defRPr sz="950" b="0">
                 <a:solidFill>
-                  <a:srgbClr val="D55E00"/>
-                </a:solidFill>
-                <a:latin typeface="Noto Sans CJK SC"/>
-              </a:defRPr>
-            </a:pPr>
-            <a:r>
-              <a:t>验证执行中｜结果待锁定</a:t>
+                  <a:srgbClr val="356E9F"/>
+                </a:solidFill>
+                <a:latin typeface="Noto Sans CJK SC"/>
+              </a:defRPr>
+            </a:pPr>
+            <a:r>
+              <a:t>锁定 Test 结果</a:t>
             </a:r>
           </a:p>
         </p:txBody>
@@ -5933,13 +5933,13 @@
             <a:pPr>
               <a:defRPr sz="950" b="0">
                 <a:solidFill>
-                  <a:srgbClr val="D55E00"/>
-                </a:solidFill>
-                <a:latin typeface="Noto Sans CJK SC"/>
-              </a:defRPr>
-            </a:pPr>
-            <a:r>
-              <a:t>验证执行中｜结果待锁定</a:t>
+                  <a:srgbClr val="356E9F"/>
+                </a:solidFill>
+                <a:latin typeface="Noto Sans CJK SC"/>
+              </a:defRPr>
+            </a:pPr>
+            <a:r>
+              <a:t>锁定 Test 结果</a:t>
             </a:r>
           </a:p>
         </p:txBody>
@@ -6265,13 +6265,13 @@
             <a:pPr>
               <a:defRPr sz="950" b="0">
                 <a:solidFill>
-                  <a:srgbClr val="D55E00"/>
-                </a:solidFill>
-                <a:latin typeface="Noto Sans CJK SC"/>
-              </a:defRPr>
-            </a:pPr>
-            <a:r>
-              <a:t>验证执行中｜结果待锁定</a:t>
+                  <a:srgbClr val="356E9F"/>
+                </a:solidFill>
+                <a:latin typeface="Noto Sans CJK SC"/>
+              </a:defRPr>
+            </a:pPr>
+            <a:r>
+              <a:t>锁定 Test 结果</a:t>
             </a:r>
           </a:p>
         </p:txBody>
@@ -6581,13 +6581,13 @@
             <a:pPr>
               <a:defRPr sz="950" b="0">
                 <a:solidFill>
-                  <a:srgbClr val="D55E00"/>
-                </a:solidFill>
-                <a:latin typeface="Noto Sans CJK SC"/>
-              </a:defRPr>
-            </a:pPr>
-            <a:r>
-              <a:t>验证执行中｜结果待锁定</a:t>
+                  <a:srgbClr val="356E9F"/>
+                </a:solidFill>
+                <a:latin typeface="Noto Sans CJK SC"/>
+              </a:defRPr>
+            </a:pPr>
+            <a:r>
+              <a:t>锁定 Test 结果</a:t>
             </a:r>
           </a:p>
         </p:txBody>
@@ -6897,13 +6897,13 @@
             <a:pPr>
               <a:defRPr sz="950" b="0">
                 <a:solidFill>
-                  <a:srgbClr val="D55E00"/>
-                </a:solidFill>
-                <a:latin typeface="Noto Sans CJK SC"/>
-              </a:defRPr>
-            </a:pPr>
-            <a:r>
-              <a:t>验证执行中｜结果待锁定</a:t>
+                  <a:srgbClr val="356E9F"/>
+                </a:solidFill>
+                <a:latin typeface="Noto Sans CJK SC"/>
+              </a:defRPr>
+            </a:pPr>
+            <a:r>
+              <a:t>锁定 Test 结果</a:t>
             </a:r>
           </a:p>
         </p:txBody>
@@ -7183,7 +7183,23 @@
               </a:defRPr>
             </a:pPr>
             <a:r>
-              <a:t>• 配对 McNemar / Wilcoxon + bootstrap 95% CI + 全局 Holm</a:t>
+              <a:t>• 到达/碰撞/超时：McNemar；连续端点：Wilcoxon + 全局 Holm</a:t>
+            </a:r>
+          </a:p>
+          <a:p>
+            <a:pPr>
+              <a:spcAft>
+                <a:spcPts val="800"/>
+              </a:spcAft>
+              <a:defRPr sz="1900">
+                <a:solidFill>
+                  <a:srgbClr val="1B1F23"/>
+                </a:solidFill>
+                <a:latin typeface="Noto Sans CJK SC"/>
+              </a:defRPr>
+            </a:pPr>
+            <a:r>
+              <a:t>• 规划失败仅做描述性率与差值，不补做事后显著性检验</a:t>
             </a:r>
           </a:p>
         </p:txBody>
@@ -7213,13 +7229,13 @@
             <a:pPr>
               <a:defRPr sz="950" b="0">
                 <a:solidFill>
-                  <a:srgbClr val="D55E00"/>
-                </a:solidFill>
-                <a:latin typeface="Noto Sans CJK SC"/>
-              </a:defRPr>
-            </a:pPr>
-            <a:r>
-              <a:t>验证执行中｜结果待锁定</a:t>
+                  <a:srgbClr val="356E9F"/>
+                </a:solidFill>
+                <a:latin typeface="Noto Sans CJK SC"/>
+              </a:defRPr>
+            </a:pPr>
+            <a:r>
+              <a:t>锁定 Test 结果</a:t>
             </a:r>
           </a:p>
         </p:txBody>
@@ -7396,7 +7412,7 @@
               </a:defRPr>
             </a:pPr>
             <a:r>
-              <a:t>只接受完整终止类别，不用安全替代完成</a:t>
+              <a:t>锁定 test：终止结果按四类完整报告</a:t>
             </a:r>
           </a:p>
         </p:txBody>
@@ -7409,88 +7425,128 @@
         </p:nvSpPr>
         <p:spPr>
           <a:xfrm>
-            <a:off x="914400" y="1719072"/>
-            <a:ext cx="10241280" cy="4389120"/>
-          </a:xfrm>
-          <a:prstGeom prst="rect">
-            <a:avLst/>
-          </a:prstGeom>
-          <a:noFill/>
-        </p:spPr>
-        <p:txBody>
-          <a:bodyPr wrap="square">
-            <a:spAutoFit/>
-          </a:bodyPr>
-          <a:lstStyle/>
-          <a:p>
-            <a:pPr>
-              <a:spcAft>
-                <a:spcPts val="800"/>
-              </a:spcAft>
-              <a:defRPr sz="1900">
-                <a:solidFill>
-                  <a:srgbClr val="1B1F23"/>
-                </a:solidFill>
-                <a:latin typeface="Noto Sans CJK SC"/>
-              </a:defRPr>
-            </a:pPr>
-            <a:r>
-              <a:t>• 阶段标识：验证执行中，结果尚未锁定</a:t>
-            </a:r>
-          </a:p>
-          <a:p>
-            <a:pPr>
-              <a:spcAft>
-                <a:spcPts val="800"/>
-              </a:spcAft>
-              <a:defRPr sz="1900">
-                <a:solidFill>
-                  <a:srgbClr val="1B1F23"/>
-                </a:solidFill>
-                <a:latin typeface="Noto Sans CJK SC"/>
-              </a:defRPr>
-            </a:pPr>
-            <a:r>
-              <a:t>• 本页计划展示：五种方法的到达、碰撞、超时与规划失败</a:t>
-            </a:r>
-          </a:p>
-          <a:p>
-            <a:pPr>
-              <a:spcAft>
-                <a:spcPts val="800"/>
-              </a:spcAft>
-              <a:defRPr sz="1900">
-                <a:solidFill>
-                  <a:srgbClr val="1B1F23"/>
-                </a:solidFill>
-                <a:latin typeface="Noto Sans CJK SC"/>
-              </a:defRPr>
-            </a:pPr>
-            <a:r>
-              <a:t>• 未读取历史 64-episode、pilot、calibration 或运行中的验证目录</a:t>
-            </a:r>
-          </a:p>
-          <a:p>
-            <a:pPr>
-              <a:spcAft>
-                <a:spcPts val="800"/>
-              </a:spcAft>
-              <a:defRPr sz="1900">
-                <a:solidFill>
-                  <a:srgbClr val="1B1F23"/>
-                </a:solidFill>
-                <a:latin typeface="Noto Sans CJK SC"/>
-              </a:defRPr>
-            </a:pPr>
-            <a:r>
-              <a:t>• 批准结果通过 split、pair、完整性与 SHA256 检查后自动覆盖本页</a:t>
-            </a:r>
-          </a:p>
-        </p:txBody>
-      </p:sp>
-      <p:sp>
-        <p:nvSpPr>
-          <p:cNvPr id="6" name="TextBox 5"/>
+            <a:off x="685800" y="1691640"/>
+            <a:ext cx="4572000" cy="4389120"/>
+          </a:xfrm>
+          <a:prstGeom prst="rect">
+            <a:avLst/>
+          </a:prstGeom>
+          <a:noFill/>
+        </p:spPr>
+        <p:txBody>
+          <a:bodyPr wrap="square">
+            <a:spAutoFit/>
+          </a:bodyPr>
+          <a:lstStyle/>
+          <a:p>
+            <a:pPr>
+              <a:spcAft>
+                <a:spcPts val="800"/>
+              </a:spcAft>
+              <a:defRPr sz="1650">
+                <a:solidFill>
+                  <a:srgbClr val="1B1F23"/>
+                </a:solidFill>
+                <a:latin typeface="Noto Sans CJK SC"/>
+              </a:defRPr>
+            </a:pPr>
+            <a:r>
+              <a:t>• 配对条件：120；方法 episode：600</a:t>
+            </a:r>
+          </a:p>
+          <a:p>
+            <a:pPr>
+              <a:spcAft>
+                <a:spcPts val="800"/>
+              </a:spcAft>
+              <a:defRPr sz="1650">
+                <a:solidFill>
+                  <a:srgbClr val="1B1F23"/>
+                </a:solidFill>
+                <a:latin typeface="Noto Sans CJK SC"/>
+              </a:defRPr>
+            </a:pPr>
+            <a:r>
+              <a:t>• DWB 到达 / 碰撞 / 超时：70.8% / 29.2% / 0.0%</a:t>
+            </a:r>
+          </a:p>
+          <a:p>
+            <a:pPr>
+              <a:spcAft>
+                <a:spcPts val="800"/>
+              </a:spcAft>
+              <a:defRPr sz="1650">
+                <a:solidFill>
+                  <a:srgbClr val="1B1F23"/>
+                </a:solidFill>
+                <a:latin typeface="Noto Sans CJK SC"/>
+              </a:defRPr>
+            </a:pPr>
+            <a:r>
+              <a:t>• PGRR 到达 / 碰撞 / 超时：90.8% / 0.0% / 1.7%</a:t>
+            </a:r>
+          </a:p>
+          <a:p>
+            <a:pPr>
+              <a:spcAft>
+                <a:spcPts val="800"/>
+              </a:spcAft>
+              <a:defRPr sz="1650">
+                <a:solidFill>
+                  <a:srgbClr val="1B1F23"/>
+                </a:solidFill>
+                <a:latin typeface="Noto Sans CJK SC"/>
+              </a:defRPr>
+            </a:pPr>
+            <a:r>
+              <a:t>• 规划失败（描述性、非预注册推断端点）：DWB 0.0%；PGRR 7.5%；差 +7.5 个百分点</a:t>
+            </a:r>
+          </a:p>
+          <a:p>
+            <a:pPr>
+              <a:spcAft>
+                <a:spcPts val="800"/>
+              </a:spcAft>
+              <a:defRPr sz="1650">
+                <a:solidFill>
+                  <a:srgbClr val="1B1F23"/>
+                </a:solidFill>
+                <a:latin typeface="Noto Sans CJK SC"/>
+              </a:defRPr>
+            </a:pPr>
+            <a:r>
+              <a:t>• 基础设施排除：0，未并入算法分母</a:t>
+            </a:r>
+          </a:p>
+        </p:txBody>
+      </p:sp>
+      <p:pic>
+        <p:nvPicPr>
+          <p:cNvPr id="6" name="Picture 5" descr="result_outcomes.png"/>
+          <p:cNvPicPr>
+            <a:picLocks noChangeAspect="1"/>
+          </p:cNvPicPr>
+          <p:nvPr/>
+        </p:nvPicPr>
+        <p:blipFill>
+          <a:blip r:embed="rId2"/>
+          <a:stretch>
+            <a:fillRect/>
+          </a:stretch>
+        </p:blipFill>
+        <p:spPr>
+          <a:xfrm>
+            <a:off x="5394960" y="2309410"/>
+            <a:ext cx="6126480" cy="3107859"/>
+          </a:xfrm>
+          <a:prstGeom prst="rect">
+            <a:avLst/>
+          </a:prstGeom>
+        </p:spPr>
+      </p:pic>
+      <p:sp>
+        <p:nvSpPr>
+          <p:cNvPr id="7" name="TextBox 6"/>
           <p:cNvSpPr txBox="1"/>
           <p:nvPr/>
         </p:nvSpPr>
@@ -7513,20 +7569,20 @@
             <a:pPr>
               <a:defRPr sz="950" b="0">
                 <a:solidFill>
-                  <a:srgbClr val="D55E00"/>
-                </a:solidFill>
-                <a:latin typeface="Noto Sans CJK SC"/>
-              </a:defRPr>
-            </a:pPr>
-            <a:r>
-              <a:t>验证执行中｜结果待锁定</a:t>
-            </a:r>
-          </a:p>
-        </p:txBody>
-      </p:sp>
-      <p:sp>
-        <p:nvSpPr>
-          <p:cNvPr id="7" name="TextBox 6"/>
+                  <a:srgbClr val="356E9F"/>
+                </a:solidFill>
+                <a:latin typeface="Noto Sans CJK SC"/>
+              </a:defRPr>
+            </a:pPr>
+            <a:r>
+              <a:t>锁定 Test 结果</a:t>
+            </a:r>
+          </a:p>
+        </p:txBody>
+      </p:sp>
+      <p:sp>
+        <p:nvSpPr>
+          <p:cNvPr id="8" name="TextBox 7"/>
           <p:cNvSpPr txBox="1"/>
           <p:nvPr/>
         </p:nvSpPr>
@@ -7696,7 +7752,7 @@
               </a:defRPr>
             </a:pPr>
             <a:r>
-              <a:t>密度效应必须展示全部 low / medium / high 单元</a:t>
+              <a:t>三档密度全部展示，不做事后子集选择</a:t>
             </a:r>
           </a:p>
         </p:txBody>
@@ -7709,88 +7765,128 @@
         </p:nvSpPr>
         <p:spPr>
           <a:xfrm>
-            <a:off x="914400" y="1719072"/>
-            <a:ext cx="10241280" cy="4389120"/>
-          </a:xfrm>
-          <a:prstGeom prst="rect">
-            <a:avLst/>
-          </a:prstGeom>
-          <a:noFill/>
-        </p:spPr>
-        <p:txBody>
-          <a:bodyPr wrap="square">
-            <a:spAutoFit/>
-          </a:bodyPr>
-          <a:lstStyle/>
-          <a:p>
-            <a:pPr>
-              <a:spcAft>
-                <a:spcPts val="800"/>
-              </a:spcAft>
-              <a:defRPr sz="1900">
-                <a:solidFill>
-                  <a:srgbClr val="1B1F23"/>
-                </a:solidFill>
-                <a:latin typeface="Noto Sans CJK SC"/>
-              </a:defRPr>
-            </a:pPr>
-            <a:r>
-              <a:t>• 阶段标识：验证执行中，结果尚未锁定</a:t>
-            </a:r>
-          </a:p>
-          <a:p>
-            <a:pPr>
-              <a:spcAft>
-                <a:spcPts val="800"/>
-              </a:spcAft>
-              <a:defRPr sz="1900">
-                <a:solidFill>
-                  <a:srgbClr val="1B1F23"/>
-                </a:solidFill>
-                <a:latin typeface="Noto Sans CJK SC"/>
-              </a:defRPr>
-            </a:pPr>
-            <a:r>
-              <a:t>• 本页计划展示：三档密度的目标到达率与样本数</a:t>
-            </a:r>
-          </a:p>
-          <a:p>
-            <a:pPr>
-              <a:spcAft>
-                <a:spcPts val="800"/>
-              </a:spcAft>
-              <a:defRPr sz="1900">
-                <a:solidFill>
-                  <a:srgbClr val="1B1F23"/>
-                </a:solidFill>
-                <a:latin typeface="Noto Sans CJK SC"/>
-              </a:defRPr>
-            </a:pPr>
-            <a:r>
-              <a:t>• 未读取历史 64-episode、pilot、calibration 或运行中的验证目录</a:t>
-            </a:r>
-          </a:p>
-          <a:p>
-            <a:pPr>
-              <a:spcAft>
-                <a:spcPts val="800"/>
-              </a:spcAft>
-              <a:defRPr sz="1900">
-                <a:solidFill>
-                  <a:srgbClr val="1B1F23"/>
-                </a:solidFill>
-                <a:latin typeface="Noto Sans CJK SC"/>
-              </a:defRPr>
-            </a:pPr>
-            <a:r>
-              <a:t>• 批准结果通过 split、pair、完整性与 SHA256 检查后自动覆盖本页</a:t>
-            </a:r>
-          </a:p>
-        </p:txBody>
-      </p:sp>
-      <p:sp>
-        <p:nvSpPr>
-          <p:cNvPr id="6" name="TextBox 5"/>
+            <a:off x="685800" y="1691640"/>
+            <a:ext cx="4572000" cy="4389120"/>
+          </a:xfrm>
+          <a:prstGeom prst="rect">
+            <a:avLst/>
+          </a:prstGeom>
+          <a:noFill/>
+        </p:spPr>
+        <p:txBody>
+          <a:bodyPr wrap="square">
+            <a:spAutoFit/>
+          </a:bodyPr>
+          <a:lstStyle/>
+          <a:p>
+            <a:pPr>
+              <a:spcAft>
+                <a:spcPts val="800"/>
+              </a:spcAft>
+              <a:defRPr sz="1650">
+                <a:solidFill>
+                  <a:srgbClr val="1B1F23"/>
+                </a:solidFill>
+                <a:latin typeface="Noto Sans CJK SC"/>
+              </a:defRPr>
+            </a:pPr>
+            <a:r>
+              <a:t>• Low：DWB 72.5%；PGRR 92.5%</a:t>
+            </a:r>
+          </a:p>
+          <a:p>
+            <a:pPr>
+              <a:spcAft>
+                <a:spcPts val="800"/>
+              </a:spcAft>
+              <a:defRPr sz="1650">
+                <a:solidFill>
+                  <a:srgbClr val="1B1F23"/>
+                </a:solidFill>
+                <a:latin typeface="Noto Sans CJK SC"/>
+              </a:defRPr>
+            </a:pPr>
+            <a:r>
+              <a:t>• Medium：DWB 72.5%；PGRR 90.0%</a:t>
+            </a:r>
+          </a:p>
+          <a:p>
+            <a:pPr>
+              <a:spcAft>
+                <a:spcPts val="800"/>
+              </a:spcAft>
+              <a:defRPr sz="1650">
+                <a:solidFill>
+                  <a:srgbClr val="1B1F23"/>
+                </a:solidFill>
+                <a:latin typeface="Noto Sans CJK SC"/>
+              </a:defRPr>
+            </a:pPr>
+            <a:r>
+              <a:t>• High：DWB 67.5%；PGRR 90.0%</a:t>
+            </a:r>
+          </a:p>
+          <a:p>
+            <a:pPr>
+              <a:spcAft>
+                <a:spcPts val="800"/>
+              </a:spcAft>
+              <a:defRPr sz="1650">
+                <a:solidFill>
+                  <a:srgbClr val="1B1F23"/>
+                </a:solidFill>
+                <a:latin typeface="Noto Sans CJK SC"/>
+              </a:defRPr>
+            </a:pPr>
+            <a:r>
+              <a:t>• 柱状图来自同一 approved results.parquet</a:t>
+            </a:r>
+          </a:p>
+          <a:p>
+            <a:pPr>
+              <a:spcAft>
+                <a:spcPts val="800"/>
+              </a:spcAft>
+              <a:defRPr sz="1650">
+                <a:solidFill>
+                  <a:srgbClr val="1B1F23"/>
+                </a:solidFill>
+                <a:latin typeface="Noto Sans CJK SC"/>
+              </a:defRPr>
+            </a:pPr>
+            <a:r>
+              <a:t>• 阶段：锁定 test</a:t>
+            </a:r>
+          </a:p>
+        </p:txBody>
+      </p:sp>
+      <p:pic>
+        <p:nvPicPr>
+          <p:cNvPr id="6" name="Picture 5" descr="result_density.png"/>
+          <p:cNvPicPr>
+            <a:picLocks noChangeAspect="1"/>
+          </p:cNvPicPr>
+          <p:nvPr/>
+        </p:nvPicPr>
+        <p:blipFill>
+          <a:blip r:embed="rId2"/>
+          <a:stretch>
+            <a:fillRect/>
+          </a:stretch>
+        </p:blipFill>
+        <p:spPr>
+          <a:xfrm>
+            <a:off x="5394960" y="2309410"/>
+            <a:ext cx="6126480" cy="3107859"/>
+          </a:xfrm>
+          <a:prstGeom prst="rect">
+            <a:avLst/>
+          </a:prstGeom>
+        </p:spPr>
+      </p:pic>
+      <p:sp>
+        <p:nvSpPr>
+          <p:cNvPr id="7" name="TextBox 6"/>
           <p:cNvSpPr txBox="1"/>
           <p:nvPr/>
         </p:nvSpPr>
@@ -7813,20 +7909,20 @@
             <a:pPr>
               <a:defRPr sz="950" b="0">
                 <a:solidFill>
-                  <a:srgbClr val="D55E00"/>
-                </a:solidFill>
-                <a:latin typeface="Noto Sans CJK SC"/>
-              </a:defRPr>
-            </a:pPr>
-            <a:r>
-              <a:t>验证执行中｜结果待锁定</a:t>
-            </a:r>
-          </a:p>
-        </p:txBody>
-      </p:sp>
-      <p:sp>
-        <p:nvSpPr>
-          <p:cNvPr id="7" name="TextBox 6"/>
+                  <a:srgbClr val="356E9F"/>
+                </a:solidFill>
+                <a:latin typeface="Noto Sans CJK SC"/>
+              </a:defRPr>
+            </a:pPr>
+            <a:r>
+              <a:t>锁定 Test 结果</a:t>
+            </a:r>
+          </a:p>
+        </p:txBody>
+      </p:sp>
+      <p:sp>
+        <p:nvSpPr>
+          <p:cNvPr id="8" name="TextBox 7"/>
           <p:cNvSpPr txBox="1"/>
           <p:nvPr/>
         </p:nvSpPr>
@@ -7996,7 +8092,7 @@
               </a:defRPr>
             </a:pPr>
             <a:r>
-              <a:t>八类场景全部公开，不能只挑有利案例</a:t>
+              <a:t>聚合结果必须回到八类交互几何检查</a:t>
             </a:r>
           </a:p>
         </p:txBody>
@@ -8009,88 +8105,112 @@
         </p:nvSpPr>
         <p:spPr>
           <a:xfrm>
-            <a:off x="914400" y="1719072"/>
-            <a:ext cx="10241280" cy="4389120"/>
-          </a:xfrm>
-          <a:prstGeom prst="rect">
-            <a:avLst/>
-          </a:prstGeom>
-          <a:noFill/>
-        </p:spPr>
-        <p:txBody>
-          <a:bodyPr wrap="square">
-            <a:spAutoFit/>
-          </a:bodyPr>
-          <a:lstStyle/>
-          <a:p>
-            <a:pPr>
-              <a:spcAft>
-                <a:spcPts val="800"/>
-              </a:spcAft>
-              <a:defRPr sz="1900">
-                <a:solidFill>
-                  <a:srgbClr val="1B1F23"/>
-                </a:solidFill>
-                <a:latin typeface="Noto Sans CJK SC"/>
-              </a:defRPr>
-            </a:pPr>
-            <a:r>
-              <a:t>• 阶段标识：验证执行中，结果尚未锁定</a:t>
-            </a:r>
-          </a:p>
-          <a:p>
-            <a:pPr>
-              <a:spcAft>
-                <a:spcPts val="800"/>
-              </a:spcAft>
-              <a:defRPr sz="1900">
-                <a:solidFill>
-                  <a:srgbClr val="1B1F23"/>
-                </a:solidFill>
-                <a:latin typeface="Noto Sans CJK SC"/>
-              </a:defRPr>
-            </a:pPr>
-            <a:r>
-              <a:t>• 本页计划展示：八个 family × 五种方法的完整目标到达矩阵</a:t>
-            </a:r>
-          </a:p>
-          <a:p>
-            <a:pPr>
-              <a:spcAft>
-                <a:spcPts val="800"/>
-              </a:spcAft>
-              <a:defRPr sz="1900">
-                <a:solidFill>
-                  <a:srgbClr val="1B1F23"/>
-                </a:solidFill>
-                <a:latin typeface="Noto Sans CJK SC"/>
-              </a:defRPr>
-            </a:pPr>
-            <a:r>
-              <a:t>• 未读取历史 64-episode、pilot、calibration 或运行中的验证目录</a:t>
-            </a:r>
-          </a:p>
-          <a:p>
-            <a:pPr>
-              <a:spcAft>
-                <a:spcPts val="800"/>
-              </a:spcAft>
-              <a:defRPr sz="1900">
-                <a:solidFill>
-                  <a:srgbClr val="1B1F23"/>
-                </a:solidFill>
-                <a:latin typeface="Noto Sans CJK SC"/>
-              </a:defRPr>
-            </a:pPr>
-            <a:r>
-              <a:t>• 批准结果通过 split、pair、完整性与 SHA256 检查后自动覆盖本页</a:t>
-            </a:r>
-          </a:p>
-        </p:txBody>
-      </p:sp>
-      <p:sp>
-        <p:nvSpPr>
-          <p:cNvPr id="6" name="TextBox 5"/>
+            <a:off x="685800" y="1691640"/>
+            <a:ext cx="4572000" cy="4389120"/>
+          </a:xfrm>
+          <a:prstGeom prst="rect">
+            <a:avLst/>
+          </a:prstGeom>
+          <a:noFill/>
+        </p:spPr>
+        <p:txBody>
+          <a:bodyPr wrap="square">
+            <a:spAutoFit/>
+          </a:bodyPr>
+          <a:lstStyle/>
+          <a:p>
+            <a:pPr>
+              <a:spcAft>
+                <a:spcPts val="800"/>
+              </a:spcAft>
+              <a:defRPr sz="1650">
+                <a:solidFill>
+                  <a:srgbClr val="1B1F23"/>
+                </a:solidFill>
+                <a:latin typeface="Noto Sans CJK SC"/>
+              </a:defRPr>
+            </a:pPr>
+            <a:r>
+              <a:t>• 每个单元显示目标到达率，覆盖全部预声明 family</a:t>
+            </a:r>
+          </a:p>
+          <a:p>
+            <a:pPr>
+              <a:spcAft>
+                <a:spcPts val="800"/>
+              </a:spcAft>
+              <a:defRPr sz="1650">
+                <a:solidFill>
+                  <a:srgbClr val="1B1F23"/>
+                </a:solidFill>
+                <a:latin typeface="Noto Sans CJK SC"/>
+              </a:defRPr>
+            </a:pPr>
+            <a:r>
+              <a:t>• 矩阵用于识别收益集中、退化和不可恢复结构</a:t>
+            </a:r>
+          </a:p>
+          <a:p>
+            <a:pPr>
+              <a:spcAft>
+                <a:spcPts val="800"/>
+              </a:spcAft>
+              <a:defRPr sz="1650">
+                <a:solidFill>
+                  <a:srgbClr val="1B1F23"/>
+                </a:solidFill>
+                <a:latin typeface="Noto Sans CJK SC"/>
+              </a:defRPr>
+            </a:pPr>
+            <a:r>
+              <a:t>• 场景差异为描述性分析，不自动构成显著性结论</a:t>
+            </a:r>
+          </a:p>
+          <a:p>
+            <a:pPr>
+              <a:spcAft>
+                <a:spcPts val="800"/>
+              </a:spcAft>
+              <a:defRPr sz="1650">
+                <a:solidFill>
+                  <a:srgbClr val="1B1F23"/>
+                </a:solidFill>
+                <a:latin typeface="Noto Sans CJK SC"/>
+              </a:defRPr>
+            </a:pPr>
+            <a:r>
+              <a:t>• 阶段：锁定 test</a:t>
+            </a:r>
+          </a:p>
+        </p:txBody>
+      </p:sp>
+      <p:pic>
+        <p:nvPicPr>
+          <p:cNvPr id="6" name="Picture 5" descr="result_family.png"/>
+          <p:cNvPicPr>
+            <a:picLocks noChangeAspect="1"/>
+          </p:cNvPicPr>
+          <p:nvPr/>
+        </p:nvPicPr>
+        <p:blipFill>
+          <a:blip r:embed="rId2"/>
+          <a:stretch>
+            <a:fillRect/>
+          </a:stretch>
+        </p:blipFill>
+        <p:spPr>
+          <a:xfrm>
+            <a:off x="5394960" y="1858063"/>
+            <a:ext cx="6126480" cy="4010553"/>
+          </a:xfrm>
+          <a:prstGeom prst="rect">
+            <a:avLst/>
+          </a:prstGeom>
+        </p:spPr>
+      </p:pic>
+      <p:sp>
+        <p:nvSpPr>
+          <p:cNvPr id="7" name="TextBox 6"/>
           <p:cNvSpPr txBox="1"/>
           <p:nvPr/>
         </p:nvSpPr>
@@ -8113,20 +8233,20 @@
             <a:pPr>
               <a:defRPr sz="950" b="0">
                 <a:solidFill>
-                  <a:srgbClr val="D55E00"/>
-                </a:solidFill>
-                <a:latin typeface="Noto Sans CJK SC"/>
-              </a:defRPr>
-            </a:pPr>
-            <a:r>
-              <a:t>验证执行中｜结果待锁定</a:t>
-            </a:r>
-          </a:p>
-        </p:txBody>
-      </p:sp>
-      <p:sp>
-        <p:nvSpPr>
-          <p:cNvPr id="7" name="TextBox 6"/>
+                  <a:srgbClr val="356E9F"/>
+                </a:solidFill>
+                <a:latin typeface="Noto Sans CJK SC"/>
+              </a:defRPr>
+            </a:pPr>
+            <a:r>
+              <a:t>锁定 Test 结果</a:t>
+            </a:r>
+          </a:p>
+        </p:txBody>
+      </p:sp>
+      <p:sp>
+        <p:nvSpPr>
+          <p:cNvPr id="8" name="TextBox 7"/>
           <p:cNvSpPr txBox="1"/>
           <p:nvPr/>
         </p:nvSpPr>
@@ -8296,98 +8416,35 @@
               </a:defRPr>
             </a:pPr>
             <a:r>
-              <a:t>配对效应与显著性必须来自锁定统计 JSON</a:t>
-            </a:r>
-          </a:p>
-        </p:txBody>
-      </p:sp>
-      <p:sp>
-        <p:nvSpPr>
-          <p:cNvPr id="5" name="TextBox 4"/>
-          <p:cNvSpPr txBox="1"/>
-          <p:nvPr/>
-        </p:nvSpPr>
-        <p:spPr>
-          <a:xfrm>
-            <a:off x="914400" y="1719072"/>
-            <a:ext cx="10241280" cy="4389120"/>
-          </a:xfrm>
-          <a:prstGeom prst="rect">
-            <a:avLst/>
-          </a:prstGeom>
-          <a:noFill/>
-        </p:spPr>
-        <p:txBody>
-          <a:bodyPr wrap="square">
-            <a:spAutoFit/>
-          </a:bodyPr>
-          <a:lstStyle/>
-          <a:p>
-            <a:pPr>
-              <a:spcAft>
-                <a:spcPts val="800"/>
-              </a:spcAft>
-              <a:defRPr sz="1900">
-                <a:solidFill>
-                  <a:srgbClr val="1B1F23"/>
-                </a:solidFill>
-                <a:latin typeface="Noto Sans CJK SC"/>
-              </a:defRPr>
-            </a:pPr>
-            <a:r>
-              <a:t>• 阶段标识：验证执行中，结果尚未锁定</a:t>
-            </a:r>
-          </a:p>
-          <a:p>
-            <a:pPr>
-              <a:spcAft>
-                <a:spcPts val="800"/>
-              </a:spcAft>
-              <a:defRPr sz="1900">
-                <a:solidFill>
-                  <a:srgbClr val="1B1F23"/>
-                </a:solidFill>
-                <a:latin typeface="Noto Sans CJK SC"/>
-              </a:defRPr>
-            </a:pPr>
-            <a:r>
-              <a:t>• 本页计划展示：PGRR 相对四个 baseline 的配对差、区间与 Holm 校正</a:t>
-            </a:r>
-          </a:p>
-          <a:p>
-            <a:pPr>
-              <a:spcAft>
-                <a:spcPts val="800"/>
-              </a:spcAft>
-              <a:defRPr sz="1900">
-                <a:solidFill>
-                  <a:srgbClr val="1B1F23"/>
-                </a:solidFill>
-                <a:latin typeface="Noto Sans CJK SC"/>
-              </a:defRPr>
-            </a:pPr>
-            <a:r>
-              <a:t>• 未读取历史 64-episode、pilot、calibration 或运行中的验证目录</a:t>
-            </a:r>
-          </a:p>
-          <a:p>
-            <a:pPr>
-              <a:spcAft>
-                <a:spcPts val="800"/>
-              </a:spcAft>
-              <a:defRPr sz="1900">
-                <a:solidFill>
-                  <a:srgbClr val="1B1F23"/>
-                </a:solidFill>
-                <a:latin typeface="Noto Sans CJK SC"/>
-              </a:defRPr>
-            </a:pPr>
-            <a:r>
-              <a:t>• 批准结果通过 split、pair、完整性与 SHA256 检查后自动覆盖本页</a:t>
-            </a:r>
-          </a:p>
-        </p:txBody>
-      </p:sp>
+              <a:t>四个 baseline × 三个终止端点均给出配对差、区间、校正 p 与效应量</a:t>
+            </a:r>
+          </a:p>
+        </p:txBody>
+      </p:sp>
+      <p:pic>
+        <p:nvPicPr>
+          <p:cNvPr id="5" name="Picture 4" descr="result_paired_effects.png"/>
+          <p:cNvPicPr>
+            <a:picLocks noChangeAspect="1"/>
+          </p:cNvPicPr>
+          <p:nvPr/>
+        </p:nvPicPr>
+        <p:blipFill>
+          <a:blip r:embed="rId2"/>
+          <a:stretch>
+            <a:fillRect/>
+          </a:stretch>
+        </p:blipFill>
+        <p:spPr>
+          <a:xfrm>
+            <a:off x="658368" y="1606424"/>
+            <a:ext cx="10881360" cy="4632703"/>
+          </a:xfrm>
+          <a:prstGeom prst="rect">
+            <a:avLst/>
+          </a:prstGeom>
+        </p:spPr>
+      </p:pic>
       <p:sp>
         <p:nvSpPr>
           <p:cNvPr id="6" name="TextBox 5"/>
@@ -8413,13 +8470,13 @@
             <a:pPr>
               <a:defRPr sz="950" b="0">
                 <a:solidFill>
-                  <a:srgbClr val="D55E00"/>
-                </a:solidFill>
-                <a:latin typeface="Noto Sans CJK SC"/>
-              </a:defRPr>
-            </a:pPr>
-            <a:r>
-              <a:t>验证执行中｜结果待锁定</a:t>
+                  <a:srgbClr val="356E9F"/>
+                </a:solidFill>
+                <a:latin typeface="Noto Sans CJK SC"/>
+              </a:defRPr>
+            </a:pPr>
+            <a:r>
+              <a:t>锁定 Test 结果</a:t>
             </a:r>
           </a:p>
         </p:txBody>
@@ -8517,7 +8574,7 @@
               </a:defRPr>
             </a:pPr>
             <a:r>
-              <a:t>安全—效率视图</a:t>
+              <a:t>共同成功条件下的配对效率</a:t>
             </a:r>
           </a:p>
         </p:txBody>
@@ -8596,7 +8653,7 @@
               </a:defRPr>
             </a:pPr>
             <a:r>
-              <a:t>安全、效率与完成率必须联合解释</a:t>
+              <a:t>只在两者都到达的同一 pair 内比较效率，并保留全部失败终局</a:t>
             </a:r>
           </a:p>
         </p:txBody>
@@ -8609,88 +8666,128 @@
         </p:nvSpPr>
         <p:spPr>
           <a:xfrm>
-            <a:off x="914400" y="1719072"/>
-            <a:ext cx="10241280" cy="4389120"/>
-          </a:xfrm>
-          <a:prstGeom prst="rect">
-            <a:avLst/>
-          </a:prstGeom>
-          <a:noFill/>
-        </p:spPr>
-        <p:txBody>
-          <a:bodyPr wrap="square">
-            <a:spAutoFit/>
-          </a:bodyPr>
-          <a:lstStyle/>
-          <a:p>
-            <a:pPr>
-              <a:spcAft>
-                <a:spcPts val="800"/>
-              </a:spcAft>
-              <a:defRPr sz="1900">
-                <a:solidFill>
-                  <a:srgbClr val="1B1F23"/>
-                </a:solidFill>
-                <a:latin typeface="Noto Sans CJK SC"/>
-              </a:defRPr>
-            </a:pPr>
-            <a:r>
-              <a:t>• 阶段标识：验证执行中，结果尚未锁定</a:t>
-            </a:r>
-          </a:p>
-          <a:p>
-            <a:pPr>
-              <a:spcAft>
-                <a:spcPts val="800"/>
-              </a:spcAft>
-              <a:defRPr sz="1900">
-                <a:solidFill>
-                  <a:srgbClr val="1B1F23"/>
-                </a:solidFill>
-                <a:latin typeface="Noto Sans CJK SC"/>
-              </a:defRPr>
-            </a:pPr>
-            <a:r>
-              <a:t>• 本页计划展示：最小人距与成功 episode 导航时间</a:t>
-            </a:r>
-          </a:p>
-          <a:p>
-            <a:pPr>
-              <a:spcAft>
-                <a:spcPts val="800"/>
-              </a:spcAft>
-              <a:defRPr sz="1900">
-                <a:solidFill>
-                  <a:srgbClr val="1B1F23"/>
-                </a:solidFill>
-                <a:latin typeface="Noto Sans CJK SC"/>
-              </a:defRPr>
-            </a:pPr>
-            <a:r>
-              <a:t>• 未读取历史 64-episode、pilot、calibration 或运行中的验证目录</a:t>
-            </a:r>
-          </a:p>
-          <a:p>
-            <a:pPr>
-              <a:spcAft>
-                <a:spcPts val="800"/>
-              </a:spcAft>
-              <a:defRPr sz="1900">
-                <a:solidFill>
-                  <a:srgbClr val="1B1F23"/>
-                </a:solidFill>
-                <a:latin typeface="Noto Sans CJK SC"/>
-              </a:defRPr>
-            </a:pPr>
-            <a:r>
-              <a:t>• 批准结果通过 split、pair、完整性与 SHA256 检查后自动覆盖本页</a:t>
-            </a:r>
-          </a:p>
-        </p:txBody>
-      </p:sp>
-      <p:sp>
-        <p:nvSpPr>
-          <p:cNvPr id="6" name="TextBox 5"/>
+            <a:off x="685800" y="1691640"/>
+            <a:ext cx="4572000" cy="4389120"/>
+          </a:xfrm>
+          <a:prstGeom prst="rect">
+            <a:avLst/>
+          </a:prstGeom>
+          <a:noFill/>
+        </p:spPr>
+        <p:txBody>
+          <a:bodyPr wrap="square">
+            <a:spAutoFit/>
+          </a:bodyPr>
+          <a:lstStyle/>
+          <a:p>
+            <a:pPr>
+              <a:spcAft>
+                <a:spcPts val="800"/>
+              </a:spcAft>
+              <a:defRPr sz="1650">
+                <a:solidFill>
+                  <a:srgbClr val="1B1F23"/>
+                </a:solidFill>
+                <a:latin typeface="Noto Sans CJK SC"/>
+              </a:defRPr>
+            </a:pPr>
+            <a:r>
+              <a:t>• 共同到达 pair：83；Base 与 PGRR 必须同时 GOAL_REACHED</a:t>
+            </a:r>
+          </a:p>
+          <a:p>
+            <a:pPr>
+              <a:spcAft>
+                <a:spcPts val="800"/>
+              </a:spcAft>
+              <a:defRPr sz="1650">
+                <a:solidFill>
+                  <a:srgbClr val="1B1F23"/>
+                </a:solidFill>
+                <a:latin typeface="Noto Sans CJK SC"/>
+              </a:defRPr>
+            </a:pPr>
+            <a:r>
+              <a:t>• 时长差 PGRR-DWB：+15.877 [+11.427, +20.834] s；Holm p=&lt;0.001</a:t>
+            </a:r>
+          </a:p>
+          <a:p>
+            <a:pPr>
+              <a:spcAft>
+                <a:spcPts val="800"/>
+              </a:spcAft>
+              <a:defRPr sz="1650">
+                <a:solidFill>
+                  <a:srgbClr val="1B1F23"/>
+                </a:solidFill>
+                <a:latin typeface="Noto Sans CJK SC"/>
+              </a:defRPr>
+            </a:pPr>
+            <a:r>
+              <a:t>• 路径差 PGRR-DWB：+1.886 [+1.205, +2.691] m；Holm p=&lt;0.001</a:t>
+            </a:r>
+          </a:p>
+          <a:p>
+            <a:pPr>
+              <a:spcAft>
+                <a:spcPts val="800"/>
+              </a:spcAft>
+              <a:defRPr sz="1650">
+                <a:solidFill>
+                  <a:srgbClr val="1B1F23"/>
+                </a:solidFill>
+                <a:latin typeface="Noto Sans CJK SC"/>
+              </a:defRPr>
+            </a:pPr>
+            <a:r>
+              <a:t>• 条件于 joint success；不能删除或替代碰撞、超时和规划失败</a:t>
+            </a:r>
+          </a:p>
+          <a:p>
+            <a:pPr>
+              <a:spcAft>
+                <a:spcPts val="800"/>
+              </a:spcAft>
+              <a:defRPr sz="1650">
+                <a:solidFill>
+                  <a:srgbClr val="1B1F23"/>
+                </a:solidFill>
+                <a:latin typeface="Noto Sans CJK SC"/>
+              </a:defRPr>
+            </a:pPr>
+            <a:r>
+              <a:t>• 阶段：锁定 test</a:t>
+            </a:r>
+          </a:p>
+        </p:txBody>
+      </p:sp>
+      <p:pic>
+        <p:nvPicPr>
+          <p:cNvPr id="6" name="Picture 5" descr="result_joint_success_efficiency.png"/>
+          <p:cNvPicPr>
+            <a:picLocks noChangeAspect="1"/>
+          </p:cNvPicPr>
+          <p:nvPr/>
+        </p:nvPicPr>
+        <p:blipFill>
+          <a:blip r:embed="rId2"/>
+          <a:stretch>
+            <a:fillRect/>
+          </a:stretch>
+        </p:blipFill>
+        <p:spPr>
+          <a:xfrm>
+            <a:off x="5394960" y="2707778"/>
+            <a:ext cx="6126480" cy="2311123"/>
+          </a:xfrm>
+          <a:prstGeom prst="rect">
+            <a:avLst/>
+          </a:prstGeom>
+        </p:spPr>
+      </p:pic>
+      <p:sp>
+        <p:nvSpPr>
+          <p:cNvPr id="7" name="TextBox 6"/>
           <p:cNvSpPr txBox="1"/>
           <p:nvPr/>
         </p:nvSpPr>
@@ -8713,20 +8810,20 @@
             <a:pPr>
               <a:defRPr sz="950" b="0">
                 <a:solidFill>
-                  <a:srgbClr val="D55E00"/>
-                </a:solidFill>
-                <a:latin typeface="Noto Sans CJK SC"/>
-              </a:defRPr>
-            </a:pPr>
-            <a:r>
-              <a:t>验证执行中｜结果待锁定</a:t>
-            </a:r>
-          </a:p>
-        </p:txBody>
-      </p:sp>
-      <p:sp>
-        <p:nvSpPr>
-          <p:cNvPr id="7" name="TextBox 6"/>
+                  <a:srgbClr val="356E9F"/>
+                </a:solidFill>
+                <a:latin typeface="Noto Sans CJK SC"/>
+              </a:defRPr>
+            </a:pPr>
+            <a:r>
+              <a:t>锁定 Test 结果</a:t>
+            </a:r>
+          </a:p>
+        </p:txBody>
+      </p:sp>
+      <p:sp>
+        <p:nvSpPr>
+          <p:cNvPr id="8" name="TextBox 7"/>
           <p:cNvSpPr txBox="1"/>
           <p:nvPr/>
         </p:nvSpPr>
@@ -8896,7 +8993,7 @@
               </a:defRPr>
             </a:pPr>
             <a:r>
-              <a:t>matched 运行页等待 hash-linked raw/Parquet sidecar</a:t>
+              <a:t>固定 matched pair 公开 Base--PGRR 空间轨迹与真实终局</a:t>
             </a:r>
           </a:p>
         </p:txBody>
@@ -8909,88 +9006,128 @@
         </p:nvSpPr>
         <p:spPr>
           <a:xfrm>
-            <a:off x="914400" y="1719072"/>
-            <a:ext cx="10241280" cy="4389120"/>
-          </a:xfrm>
-          <a:prstGeom prst="rect">
-            <a:avLst/>
-          </a:prstGeom>
-          <a:noFill/>
-        </p:spPr>
-        <p:txBody>
-          <a:bodyPr wrap="square">
-            <a:spAutoFit/>
-          </a:bodyPr>
-          <a:lstStyle/>
-          <a:p>
-            <a:pPr>
-              <a:spcAft>
-                <a:spcPts val="800"/>
-              </a:spcAft>
-              <a:defRPr sz="1900">
-                <a:solidFill>
-                  <a:srgbClr val="1B1F23"/>
-                </a:solidFill>
-                <a:latin typeface="Noto Sans CJK SC"/>
-              </a:defRPr>
-            </a:pPr>
-            <a:r>
-              <a:t>• 阶段标识：验证执行中，结果尚未锁定</a:t>
-            </a:r>
-          </a:p>
-          <a:p>
-            <a:pPr>
-              <a:spcAft>
-                <a:spcPts val="800"/>
-              </a:spcAft>
-              <a:defRPr sz="1900">
-                <a:solidFill>
-                  <a:srgbClr val="1B1F23"/>
-                </a:solidFill>
-                <a:latin typeface="Noto Sans CJK SC"/>
-              </a:defRPr>
-            </a:pPr>
-            <a:r>
-              <a:t>• 本页计划展示：预注册 doorway/medium/r00 的 Base--PGRR 空间轨迹与事件时间线；遥测重建，不是 camera screenshot</a:t>
-            </a:r>
-          </a:p>
-          <a:p>
-            <a:pPr>
-              <a:spcAft>
-                <a:spcPts val="800"/>
-              </a:spcAft>
-              <a:defRPr sz="1900">
-                <a:solidFill>
-                  <a:srgbClr val="1B1F23"/>
-                </a:solidFill>
-                <a:latin typeface="Noto Sans CJK SC"/>
-              </a:defRPr>
-            </a:pPr>
-            <a:r>
-              <a:t>• 未读取历史 64-episode、pilot、calibration 或运行中的验证目录</a:t>
-            </a:r>
-          </a:p>
-          <a:p>
-            <a:pPr>
-              <a:spcAft>
-                <a:spcPts val="800"/>
-              </a:spcAft>
-              <a:defRPr sz="1900">
-                <a:solidFill>
-                  <a:srgbClr val="1B1F23"/>
-                </a:solidFill>
-                <a:latin typeface="Noto Sans CJK SC"/>
-              </a:defRPr>
-            </a:pPr>
-            <a:r>
-              <a:t>• 批准结果通过 split、pair、完整性与 SHA256 检查后自动覆盖本页</a:t>
-            </a:r>
-          </a:p>
-        </p:txBody>
-      </p:sp>
-      <p:sp>
-        <p:nvSpPr>
-          <p:cNvPr id="6" name="TextBox 5"/>
+            <a:off x="685800" y="1691640"/>
+            <a:ext cx="4572000" cy="4389120"/>
+          </a:xfrm>
+          <a:prstGeom prst="rect">
+            <a:avLst/>
+          </a:prstGeom>
+          <a:noFill/>
+        </p:spPr>
+        <p:txBody>
+          <a:bodyPr wrap="square">
+            <a:spAutoFit/>
+          </a:bodyPr>
+          <a:lstStyle/>
+          <a:p>
+            <a:pPr>
+              <a:spcAft>
+                <a:spcPts val="800"/>
+              </a:spcAft>
+              <a:defRPr sz="1650">
+                <a:solidFill>
+                  <a:srgbClr val="1B1F23"/>
+                </a:solidFill>
+                <a:latin typeface="Noto Sans CJK SC"/>
+              </a:defRPr>
+            </a:pPr>
+            <a:r>
+              <a:t>• 选择规则：eligible: PGRR trigger + configured static geometry + actor routes; order: Base failure/PGRR goal, outcome contrast, PGRR goal, density, trigger count, family, seed, pair_id</a:t>
+            </a:r>
+          </a:p>
+          <a:p>
+            <a:pPr>
+              <a:spcAft>
+                <a:spcPts val="800"/>
+              </a:spcAft>
+              <a:defRPr sz="1650">
+                <a:solidFill>
+                  <a:srgbClr val="1B1F23"/>
+                </a:solidFill>
+                <a:latin typeface="Noto Sans CJK SC"/>
+              </a:defRPr>
+            </a:pPr>
+            <a:r>
+              <a:t>• DWB 终局：COLLISION；raw SHA 3b2969e6d15e</a:t>
+            </a:r>
+          </a:p>
+          <a:p>
+            <a:pPr>
+              <a:spcAft>
+                <a:spcPts val="800"/>
+              </a:spcAft>
+              <a:defRPr sz="1650">
+                <a:solidFill>
+                  <a:srgbClr val="1B1F23"/>
+                </a:solidFill>
+                <a:latin typeface="Noto Sans CJK SC"/>
+              </a:defRPr>
+            </a:pPr>
+            <a:r>
+              <a:t>• PGRR 终局：GOAL_REACHED；raw SHA 7c81c150788a</a:t>
+            </a:r>
+          </a:p>
+          <a:p>
+            <a:pPr>
+              <a:spcAft>
+                <a:spcPts val="800"/>
+              </a:spcAft>
+              <a:defRPr sz="1650">
+                <a:solidFill>
+                  <a:srgbClr val="1B1F23"/>
+                </a:solidFill>
+                <a:latin typeface="Noto Sans CJK SC"/>
+              </a:defRPr>
+            </a:pPr>
+            <a:r>
+              <a:t>• pair：blind_corner_high_test_moderate_v6_r00_s87320_seed87320；scenario：blind_corner_high_test_moderate_v6_r00_s87320</a:t>
+            </a:r>
+          </a:p>
+          <a:p>
+            <a:pPr>
+              <a:spcAft>
+                <a:spcPts val="800"/>
+              </a:spcAft>
+              <a:defRPr sz="1650">
+                <a:solidFill>
+                  <a:srgbClr val="1B1F23"/>
+                </a:solidFill>
+                <a:latin typeface="Noto Sans CJK SC"/>
+              </a:defRPr>
+            </a:pPr>
+            <a:r>
+              <a:t>• 轨迹是 JSONL/Parquet 遥测重建，不是 camera screenshot</a:t>
+            </a:r>
+          </a:p>
+        </p:txBody>
+      </p:sp>
+      <p:pic>
+        <p:nvPicPr>
+          <p:cNvPr id="6" name="Picture 5" descr="result_matched_trajectory.png"/>
+          <p:cNvPicPr>
+            <a:picLocks noChangeAspect="1"/>
+          </p:cNvPicPr>
+          <p:nvPr/>
+        </p:nvPicPr>
+        <p:blipFill>
+          <a:blip r:embed="rId2"/>
+          <a:stretch>
+            <a:fillRect/>
+          </a:stretch>
+        </p:blipFill>
+        <p:spPr>
+          <a:xfrm>
+            <a:off x="5394960" y="2130083"/>
+            <a:ext cx="6126480" cy="3466512"/>
+          </a:xfrm>
+          <a:prstGeom prst="rect">
+            <a:avLst/>
+          </a:prstGeom>
+        </p:spPr>
+      </p:pic>
+      <p:sp>
+        <p:nvSpPr>
+          <p:cNvPr id="7" name="TextBox 6"/>
           <p:cNvSpPr txBox="1"/>
           <p:nvPr/>
         </p:nvSpPr>
@@ -9013,20 +9150,20 @@
             <a:pPr>
               <a:defRPr sz="950" b="0">
                 <a:solidFill>
-                  <a:srgbClr val="D55E00"/>
-                </a:solidFill>
-                <a:latin typeface="Noto Sans CJK SC"/>
-              </a:defRPr>
-            </a:pPr>
-            <a:r>
-              <a:t>验证执行中｜结果待锁定</a:t>
-            </a:r>
-          </a:p>
-        </p:txBody>
-      </p:sp>
-      <p:sp>
-        <p:nvSpPr>
-          <p:cNvPr id="7" name="TextBox 6"/>
+                  <a:srgbClr val="356E9F"/>
+                </a:solidFill>
+                <a:latin typeface="Noto Sans CJK SC"/>
+              </a:defRPr>
+            </a:pPr>
+            <a:r>
+              <a:t>锁定 Test 结果</a:t>
+            </a:r>
+          </a:p>
+        </p:txBody>
+      </p:sp>
+      <p:sp>
+        <p:nvSpPr>
+          <p:cNvPr id="8" name="TextBox 7"/>
           <p:cNvSpPr txBox="1"/>
           <p:nvPr/>
         </p:nvSpPr>
@@ -9196,7 +9333,7 @@
               </a:defRPr>
             </a:pPr>
             <a:r>
-              <a:t>恢复时序素材与轨迹素材必须来自同一 test pair</a:t>
+              <a:t>恢复触发、状态切换和目标进展来自同一 PGRR raw stream</a:t>
             </a:r>
           </a:p>
         </p:txBody>
@@ -9209,88 +9346,128 @@
         </p:nvSpPr>
         <p:spPr>
           <a:xfrm>
-            <a:off x="914400" y="1719072"/>
-            <a:ext cx="10241280" cy="4389120"/>
-          </a:xfrm>
-          <a:prstGeom prst="rect">
-            <a:avLst/>
-          </a:prstGeom>
-          <a:noFill/>
-        </p:spPr>
-        <p:txBody>
-          <a:bodyPr wrap="square">
-            <a:spAutoFit/>
-          </a:bodyPr>
-          <a:lstStyle/>
-          <a:p>
-            <a:pPr>
-              <a:spcAft>
-                <a:spcPts val="800"/>
-              </a:spcAft>
-              <a:defRPr sz="1900">
-                <a:solidFill>
-                  <a:srgbClr val="1B1F23"/>
-                </a:solidFill>
-                <a:latin typeface="Noto Sans CJK SC"/>
-              </a:defRPr>
-            </a:pPr>
-            <a:r>
-              <a:t>• 阶段标识：验证执行中，结果尚未锁定</a:t>
-            </a:r>
-          </a:p>
-          <a:p>
-            <a:pPr>
-              <a:spcAft>
-                <a:spcPts val="800"/>
-              </a:spcAft>
-              <a:defRPr sz="1900">
-                <a:solidFill>
-                  <a:srgbClr val="1B1F23"/>
-                </a:solidFill>
-                <a:latin typeface="Noto Sans CJK SC"/>
-              </a:defRPr>
-            </a:pPr>
-            <a:r>
-              <a:t>• 本页计划展示：固定文件名的 PGRR 目标距离、failure score、恢复状态与触发时间线；遥测重建，不是 camera screenshot</a:t>
-            </a:r>
-          </a:p>
-          <a:p>
-            <a:pPr>
-              <a:spcAft>
-                <a:spcPts val="800"/>
-              </a:spcAft>
-              <a:defRPr sz="1900">
-                <a:solidFill>
-                  <a:srgbClr val="1B1F23"/>
-                </a:solidFill>
-                <a:latin typeface="Noto Sans CJK SC"/>
-              </a:defRPr>
-            </a:pPr>
-            <a:r>
-              <a:t>• 未读取历史 64-episode、pilot、calibration 或运行中的验证目录</a:t>
-            </a:r>
-          </a:p>
-          <a:p>
-            <a:pPr>
-              <a:spcAft>
-                <a:spcPts val="800"/>
-              </a:spcAft>
-              <a:defRPr sz="1900">
-                <a:solidFill>
-                  <a:srgbClr val="1B1F23"/>
-                </a:solidFill>
-                <a:latin typeface="Noto Sans CJK SC"/>
-              </a:defRPr>
-            </a:pPr>
-            <a:r>
-              <a:t>• 批准结果通过 split、pair、完整性与 SHA256 检查后自动覆盖本页</a:t>
-            </a:r>
-          </a:p>
-        </p:txBody>
-      </p:sp>
-      <p:sp>
-        <p:nvSpPr>
-          <p:cNvPr id="6" name="TextBox 5"/>
+            <a:off x="685800" y="1691640"/>
+            <a:ext cx="4572000" cy="4389120"/>
+          </a:xfrm>
+          <a:prstGeom prst="rect">
+            <a:avLst/>
+          </a:prstGeom>
+          <a:noFill/>
+        </p:spPr>
+        <p:txBody>
+          <a:bodyPr wrap="square">
+            <a:spAutoFit/>
+          </a:bodyPr>
+          <a:lstStyle/>
+          <a:p>
+            <a:pPr>
+              <a:spcAft>
+                <a:spcPts val="800"/>
+              </a:spcAft>
+              <a:defRPr sz="1650">
+                <a:solidFill>
+                  <a:srgbClr val="1B1F23"/>
+                </a:solidFill>
+                <a:latin typeface="Noto Sans CJK SC"/>
+              </a:defRPr>
+            </a:pPr>
+            <a:r>
+              <a:t>• pair：blind_corner_high_test_moderate_v6_r00_s87320_seed87320；PGRR episode：blind_corner_high_test_moderate_v6_r00_s87320_eval_pgrr_r95ec74c511bb_a0_dwb</a:t>
+            </a:r>
+          </a:p>
+          <a:p>
+            <a:pPr>
+              <a:spcAft>
+                <a:spcPts val="800"/>
+              </a:spcAft>
+              <a:defRPr sz="1650">
+                <a:solidFill>
+                  <a:srgbClr val="1B1F23"/>
+                </a:solidFill>
+                <a:latin typeface="Noto Sans CJK SC"/>
+              </a:defRPr>
+            </a:pPr>
+            <a:r>
+              <a:t>• PGRR 终局：GOAL_REACHED；raw SHA 7c81c150788a</a:t>
+            </a:r>
+          </a:p>
+          <a:p>
+            <a:pPr>
+              <a:spcAft>
+                <a:spcPts val="800"/>
+              </a:spcAft>
+              <a:defRPr sz="1650">
+                <a:solidFill>
+                  <a:srgbClr val="1B1F23"/>
+                </a:solidFill>
+                <a:latin typeface="Noto Sans CJK SC"/>
+              </a:defRPr>
+            </a:pPr>
+            <a:r>
+              <a:t>• 时间线包含记录的目标距离、failure score、恢复状态与触发事件</a:t>
+            </a:r>
+          </a:p>
+          <a:p>
+            <a:pPr>
+              <a:spcAft>
+                <a:spcPts val="800"/>
+              </a:spcAft>
+              <a:defRPr sz="1650">
+                <a:solidFill>
+                  <a:srgbClr val="1B1F23"/>
+                </a:solidFill>
+                <a:latin typeface="Noto Sans CJK SC"/>
+              </a:defRPr>
+            </a:pPr>
+            <a:r>
+              <a:t>• 时间线是 telemetry reconstruction，不是 camera screenshot</a:t>
+            </a:r>
+          </a:p>
+          <a:p>
+            <a:pPr>
+              <a:spcAft>
+                <a:spcPts val="800"/>
+              </a:spcAft>
+              <a:defRPr sz="1650">
+                <a:solidFill>
+                  <a:srgbClr val="1B1F23"/>
+                </a:solidFill>
+                <a:latin typeface="Noto Sans CJK SC"/>
+              </a:defRPr>
+            </a:pPr>
+            <a:r>
+              <a:t>• n=1 描述性运行证据；总体结论仍来自完整 outcome 分解</a:t>
+            </a:r>
+          </a:p>
+        </p:txBody>
+      </p:sp>
+      <p:pic>
+        <p:nvPicPr>
+          <p:cNvPr id="6" name="Picture 5" descr="result_matched_recovery_timeline.png"/>
+          <p:cNvPicPr>
+            <a:picLocks noChangeAspect="1"/>
+          </p:cNvPicPr>
+          <p:nvPr/>
+        </p:nvPicPr>
+        <p:blipFill>
+          <a:blip r:embed="rId2"/>
+          <a:stretch>
+            <a:fillRect/>
+          </a:stretch>
+        </p:blipFill>
+        <p:spPr>
+          <a:xfrm>
+            <a:off x="5394960" y="1702370"/>
+            <a:ext cx="6126480" cy="4321938"/>
+          </a:xfrm>
+          <a:prstGeom prst="rect">
+            <a:avLst/>
+          </a:prstGeom>
+        </p:spPr>
+      </p:pic>
+      <p:sp>
+        <p:nvSpPr>
+          <p:cNvPr id="7" name="TextBox 6"/>
           <p:cNvSpPr txBox="1"/>
           <p:nvPr/>
         </p:nvSpPr>
@@ -9313,20 +9490,20 @@
             <a:pPr>
               <a:defRPr sz="950" b="0">
                 <a:solidFill>
-                  <a:srgbClr val="D55E00"/>
-                </a:solidFill>
-                <a:latin typeface="Noto Sans CJK SC"/>
-              </a:defRPr>
-            </a:pPr>
-            <a:r>
-              <a:t>验证执行中｜结果待锁定</a:t>
-            </a:r>
-          </a:p>
-        </p:txBody>
-      </p:sp>
-      <p:sp>
-        <p:nvSpPr>
-          <p:cNvPr id="7" name="TextBox 6"/>
+                  <a:srgbClr val="356E9F"/>
+                </a:solidFill>
+                <a:latin typeface="Noto Sans CJK SC"/>
+              </a:defRPr>
+            </a:pPr>
+            <a:r>
+              <a:t>锁定 Test 结果</a:t>
+            </a:r>
+          </a:p>
+        </p:txBody>
+      </p:sp>
+      <p:sp>
+        <p:nvSpPr>
+          <p:cNvPr id="8" name="TextBox 7"/>
           <p:cNvSpPr txBox="1"/>
           <p:nvPr/>
         </p:nvSpPr>
@@ -9653,13 +9830,13 @@
             <a:pPr>
               <a:defRPr sz="950" b="0">
                 <a:solidFill>
-                  <a:srgbClr val="D55E00"/>
-                </a:solidFill>
-                <a:latin typeface="Noto Sans CJK SC"/>
-              </a:defRPr>
-            </a:pPr>
-            <a:r>
-              <a:t>验证执行中｜结果待锁定</a:t>
+                  <a:srgbClr val="356E9F"/>
+                </a:solidFill>
+                <a:latin typeface="Noto Sans CJK SC"/>
+              </a:defRPr>
+            </a:pPr>
+            <a:r>
+              <a:t>锁定 Test 结果</a:t>
             </a:r>
           </a:p>
         </p:txBody>
@@ -9969,13 +10146,13 @@
             <a:pPr>
               <a:defRPr sz="950" b="0">
                 <a:solidFill>
-                  <a:srgbClr val="D55E00"/>
-                </a:solidFill>
-                <a:latin typeface="Noto Sans CJK SC"/>
-              </a:defRPr>
-            </a:pPr>
-            <a:r>
-              <a:t>验证执行中｜结果待锁定</a:t>
+                  <a:srgbClr val="356E9F"/>
+                </a:solidFill>
+                <a:latin typeface="Noto Sans CJK SC"/>
+              </a:defRPr>
+            </a:pPr>
+            <a:r>
+              <a:t>锁定 Test 结果</a:t>
             </a:r>
           </a:p>
         </p:txBody>
@@ -10293,13 +10470,13 @@
             <a:pPr>
               <a:defRPr sz="950" b="0">
                 <a:solidFill>
-                  <a:srgbClr val="D55E00"/>
-                </a:solidFill>
-                <a:latin typeface="Noto Sans CJK SC"/>
-              </a:defRPr>
-            </a:pPr>
-            <a:r>
-              <a:t>验证执行中｜结果待锁定</a:t>
+                  <a:srgbClr val="356E9F"/>
+                </a:solidFill>
+                <a:latin typeface="Noto Sans CJK SC"/>
+              </a:defRPr>
+            </a:pPr>
+            <a:r>
+              <a:t>锁定 Test 结果</a:t>
             </a:r>
           </a:p>
         </p:txBody>
@@ -10579,7 +10756,7 @@
               </a:defRPr>
             </a:pPr>
             <a:r>
-              <a:t>• 当前汇报阶段：验证执行中｜数值待锁定</a:t>
+              <a:t>• 当前汇报阶段：锁定 Test 结果</a:t>
             </a:r>
           </a:p>
         </p:txBody>
@@ -10633,13 +10810,13 @@
             <a:pPr>
               <a:defRPr sz="950" b="0">
                 <a:solidFill>
-                  <a:srgbClr val="D55E00"/>
-                </a:solidFill>
-                <a:latin typeface="Noto Sans CJK SC"/>
-              </a:defRPr>
-            </a:pPr>
-            <a:r>
-              <a:t>验证执行中｜结果待锁定</a:t>
+                  <a:srgbClr val="356E9F"/>
+                </a:solidFill>
+                <a:latin typeface="Noto Sans CJK SC"/>
+              </a:defRPr>
+            </a:pPr>
+            <a:r>
+              <a:t>锁定 Test 结果</a:t>
             </a:r>
           </a:p>
         </p:txBody>
@@ -10949,13 +11126,13 @@
             <a:pPr>
               <a:defRPr sz="950" b="0">
                 <a:solidFill>
-                  <a:srgbClr val="D55E00"/>
-                </a:solidFill>
-                <a:latin typeface="Noto Sans CJK SC"/>
-              </a:defRPr>
-            </a:pPr>
-            <a:r>
-              <a:t>验证执行中｜结果待锁定</a:t>
+                  <a:srgbClr val="356E9F"/>
+                </a:solidFill>
+                <a:latin typeface="Noto Sans CJK SC"/>
+              </a:defRPr>
+            </a:pPr>
+            <a:r>
+              <a:t>锁定 Test 结果</a:t>
             </a:r>
           </a:p>
         </p:txBody>
@@ -11249,13 +11426,13 @@
             <a:pPr>
               <a:defRPr sz="950" b="0">
                 <a:solidFill>
-                  <a:srgbClr val="D55E00"/>
-                </a:solidFill>
-                <a:latin typeface="Noto Sans CJK SC"/>
-              </a:defRPr>
-            </a:pPr>
-            <a:r>
-              <a:t>验证执行中｜结果待锁定</a:t>
+                  <a:srgbClr val="356E9F"/>
+                </a:solidFill>
+                <a:latin typeface="Noto Sans CJK SC"/>
+              </a:defRPr>
+            </a:pPr>
+            <a:r>
+              <a:t>锁定 Test 结果</a:t>
             </a:r>
           </a:p>
         </p:txBody>
@@ -11565,13 +11742,13 @@
             <a:pPr>
               <a:defRPr sz="950" b="0">
                 <a:solidFill>
-                  <a:srgbClr val="D55E00"/>
-                </a:solidFill>
-                <a:latin typeface="Noto Sans CJK SC"/>
-              </a:defRPr>
-            </a:pPr>
-            <a:r>
-              <a:t>验证执行中｜结果待锁定</a:t>
+                  <a:srgbClr val="356E9F"/>
+                </a:solidFill>
+                <a:latin typeface="Noto Sans CJK SC"/>
+              </a:defRPr>
+            </a:pPr>
+            <a:r>
+              <a:t>锁定 Test 结果</a:t>
             </a:r>
           </a:p>
         </p:txBody>
@@ -11889,13 +12066,13 @@
             <a:pPr>
               <a:defRPr sz="950" b="0">
                 <a:solidFill>
-                  <a:srgbClr val="D55E00"/>
-                </a:solidFill>
-                <a:latin typeface="Noto Sans CJK SC"/>
-              </a:defRPr>
-            </a:pPr>
-            <a:r>
-              <a:t>验证执行中｜结果待锁定</a:t>
+                  <a:srgbClr val="356E9F"/>
+                </a:solidFill>
+                <a:latin typeface="Noto Sans CJK SC"/>
+              </a:defRPr>
+            </a:pPr>
+            <a:r>
+              <a:t>锁定 Test 结果</a:t>
             </a:r>
           </a:p>
         </p:txBody>
@@ -12205,13 +12382,13 @@
             <a:pPr>
               <a:defRPr sz="950" b="0">
                 <a:solidFill>
-                  <a:srgbClr val="D55E00"/>
-                </a:solidFill>
-                <a:latin typeface="Noto Sans CJK SC"/>
-              </a:defRPr>
-            </a:pPr>
-            <a:r>
-              <a:t>验证执行中｜结果待锁定</a:t>
+                  <a:srgbClr val="356E9F"/>
+                </a:solidFill>
+                <a:latin typeface="Noto Sans CJK SC"/>
+              </a:defRPr>
+            </a:pPr>
+            <a:r>
+              <a:t>锁定 Test 结果</a:t>
             </a:r>
           </a:p>
         </p:txBody>
@@ -12529,13 +12706,13 @@
             <a:pPr>
               <a:defRPr sz="950" b="0">
                 <a:solidFill>
-                  <a:srgbClr val="D55E00"/>
-                </a:solidFill>
-                <a:latin typeface="Noto Sans CJK SC"/>
-              </a:defRPr>
-            </a:pPr>
-            <a:r>
-              <a:t>验证执行中｜结果待锁定</a:t>
+                  <a:srgbClr val="356E9F"/>
+                </a:solidFill>
+                <a:latin typeface="Noto Sans CJK SC"/>
+              </a:defRPr>
+            </a:pPr>
+            <a:r>
+              <a:t>锁定 Test 结果</a:t>
             </a:r>
           </a:p>
         </p:txBody>

</xml_diff>

<commit_message>
release: publish illustrated algorithm briefing
</commit_message>
<xml_diff>
--- a/presentation/PGRR_report_zh.pptx
+++ b/presentation/PGRR_report_zh.pptx
@@ -3421,7 +3421,7 @@
               </a:defRPr>
             </a:pPr>
             <a:r>
-              <a:t>Action Mask：先排除不可执行动作</a:t>
+              <a:t>25 个恢复动作 + Action Mask</a:t>
             </a:r>
           </a:p>
         </p:txBody>
@@ -3500,7 +3500,7 @@
               </a:defRPr>
             </a:pPr>
             <a:r>
-              <a:t>策略只能在物理和规划上可行的候选集合内选择</a:t>
+              <a:t>学习策略只在规划可行的高层动作中选择，临时目标仍由 DWB 跟踪</a:t>
             </a:r>
           </a:p>
         </p:txBody>
@@ -3513,25 +3513,57 @@
         </p:nvSpPr>
         <p:spPr>
           <a:xfrm>
-            <a:off x="914400" y="1719072"/>
-            <a:ext cx="10241280" cy="4389120"/>
-          </a:xfrm>
-          <a:prstGeom prst="rect">
-            <a:avLst/>
-          </a:prstGeom>
-          <a:noFill/>
-        </p:spPr>
-        <p:txBody>
-          <a:bodyPr wrap="square">
-            <a:spAutoFit/>
-          </a:bodyPr>
-          <a:lstStyle/>
-          <a:p>
-            <a:pPr>
-              <a:spcAft>
-                <a:spcPts val="800"/>
-              </a:spcAft>
-              <a:defRPr sz="1900">
+            <a:off x="685800" y="1691640"/>
+            <a:ext cx="4572000" cy="4389120"/>
+          </a:xfrm>
+          <a:prstGeom prst="rect">
+            <a:avLst/>
+          </a:prstGeom>
+          <a:noFill/>
+        </p:spPr>
+        <p:txBody>
+          <a:bodyPr wrap="square">
+            <a:spAutoFit/>
+          </a:bodyPr>
+          <a:lstStyle/>
+          <a:p>
+            <a:pPr>
+              <a:spcAft>
+                <a:spcPts val="800"/>
+              </a:spcAft>
+              <a:defRPr sz="1650">
+                <a:solidFill>
+                  <a:srgbClr val="1B1F23"/>
+                </a:solidFill>
+                <a:latin typeface="Noto Sans CJK SC"/>
+              </a:defRPr>
+            </a:pPr>
+            <a:r>
+              <a:t>• 21 个临时子目标：3 个半径 × 7 个相对方向</a:t>
+            </a:r>
+          </a:p>
+          <a:p>
+            <a:pPr>
+              <a:spcAft>
+                <a:spcPts val="800"/>
+              </a:spcAft>
+              <a:defRPr sz="1650">
+                <a:solidFill>
+                  <a:srgbClr val="1B1F23"/>
+                </a:solidFill>
+                <a:latin typeface="Noto Sans CJK SC"/>
+              </a:defRPr>
+            </a:pPr>
+            <a:r>
+              <a:t>• WAIT、BACKUP、REPLAN、CONTINUE 四个离散行为</a:t>
+            </a:r>
+          </a:p>
+          <a:p>
+            <a:pPr>
+              <a:spcAft>
+                <a:spcPts val="800"/>
+              </a:spcAft>
+              <a:defRPr sz="1650">
                 <a:solidFill>
                   <a:srgbClr val="1B1F23"/>
                 </a:solidFill>
@@ -3547,23 +3579,7 @@
               <a:spcAft>
                 <a:spcPts val="800"/>
               </a:spcAft>
-              <a:defRPr sz="1900">
-                <a:solidFill>
-                  <a:srgbClr val="1B1F23"/>
-                </a:solidFill>
-                <a:latin typeface="Noto Sans CJK SC"/>
-              </a:defRPr>
-            </a:pPr>
-            <a:r>
-              <a:t>• 明显进入动态占据区的子目标被屏蔽</a:t>
-            </a:r>
-          </a:p>
-          <a:p>
-            <a:pPr>
-              <a:spcAft>
-                <a:spcPts val="800"/>
-              </a:spcAft>
-              <a:defRPr sz="1900">
+              <a:defRPr sz="1650">
                 <a:solidFill>
                   <a:srgbClr val="1B1F23"/>
                 </a:solidFill>
@@ -3579,23 +3595,7 @@
               <a:spcAft>
                 <a:spcPts val="800"/>
               </a:spcAft>
-              <a:defRPr sz="1900">
-                <a:solidFill>
-                  <a:srgbClr val="1B1F23"/>
-                </a:solidFill>
-                <a:latin typeface="Noto Sans CJK SC"/>
-              </a:defRPr>
-            </a:pPr>
-            <a:r>
-              <a:t>• 规划接口不可用时禁止 REPLAN</a:t>
-            </a:r>
-          </a:p>
-          <a:p>
-            <a:pPr>
-              <a:spcAft>
-                <a:spcPts val="800"/>
-              </a:spcAft>
-              <a:defRPr sz="1900">
+              <a:defRPr sz="1650">
                 <a:solidFill>
                   <a:srgbClr val="1B1F23"/>
                 </a:solidFill>
@@ -3608,9 +3608,33 @@
           </a:p>
         </p:txBody>
       </p:sp>
-      <p:sp>
-        <p:nvSpPr>
-          <p:cNvPr id="6" name="TextBox 5"/>
+      <p:pic>
+        <p:nvPicPr>
+          <p:cNvPr id="6" name="Picture 5" descr="action_space_expert.png"/>
+          <p:cNvPicPr>
+            <a:picLocks noChangeAspect="1"/>
+          </p:cNvPicPr>
+          <p:nvPr/>
+        </p:nvPicPr>
+        <p:blipFill>
+          <a:blip r:embed="rId2"/>
+          <a:stretch>
+            <a:fillRect/>
+          </a:stretch>
+        </p:blipFill>
+        <p:spPr>
+          <a:xfrm>
+            <a:off x="5394960" y="2331720"/>
+            <a:ext cx="6126480" cy="3063240"/>
+          </a:xfrm>
+          <a:prstGeom prst="rect">
+            <a:avLst/>
+          </a:prstGeom>
+        </p:spPr>
+      </p:pic>
+      <p:sp>
+        <p:nvSpPr>
+          <p:cNvPr id="7" name="TextBox 6"/>
           <p:cNvSpPr txBox="1"/>
           <p:nvPr/>
         </p:nvSpPr>
@@ -3646,7 +3670,7 @@
       </p:sp>
       <p:sp>
         <p:nvSpPr>
-          <p:cNvPr id="7" name="TextBox 6"/>
+          <p:cNvPr id="8" name="TextBox 7"/>
           <p:cNvSpPr txBox="1"/>
           <p:nvPr/>
         </p:nvSpPr>
@@ -3829,25 +3853,25 @@
         </p:nvSpPr>
         <p:spPr>
           <a:xfrm>
-            <a:off x="914400" y="1719072"/>
-            <a:ext cx="10241280" cy="4389120"/>
-          </a:xfrm>
-          <a:prstGeom prst="rect">
-            <a:avLst/>
-          </a:prstGeom>
-          <a:noFill/>
-        </p:spPr>
-        <p:txBody>
-          <a:bodyPr wrap="square">
-            <a:spAutoFit/>
-          </a:bodyPr>
-          <a:lstStyle/>
-          <a:p>
-            <a:pPr>
-              <a:spcAft>
-                <a:spcPts val="800"/>
-              </a:spcAft>
-              <a:defRPr sz="1900">
+            <a:off x="685800" y="1691640"/>
+            <a:ext cx="4572000" cy="4389120"/>
+          </a:xfrm>
+          <a:prstGeom prst="rect">
+            <a:avLst/>
+          </a:prstGeom>
+          <a:noFill/>
+        </p:spPr>
+        <p:txBody>
+          <a:bodyPr wrap="square">
+            <a:spAutoFit/>
+          </a:bodyPr>
+          <a:lstStyle/>
+          <a:p>
+            <a:pPr>
+              <a:spcAft>
+                <a:spcPts val="800"/>
+              </a:spcAft>
+              <a:defRPr sz="1650">
                 <a:solidFill>
                   <a:srgbClr val="1B1F23"/>
                 </a:solidFill>
@@ -3863,7 +3887,7 @@
               <a:spcAft>
                 <a:spcPts val="800"/>
               </a:spcAft>
-              <a:defRPr sz="1900">
+              <a:defRPr sz="1650">
                 <a:solidFill>
                   <a:srgbClr val="1B1F23"/>
                 </a:solidFill>
@@ -3879,7 +3903,7 @@
               <a:spcAft>
                 <a:spcPts val="800"/>
               </a:spcAft>
-              <a:defRPr sz="1900">
+              <a:defRPr sz="1650">
                 <a:solidFill>
                   <a:srgbClr val="1B1F23"/>
                 </a:solidFill>
@@ -3895,7 +3919,7 @@
               <a:spcAft>
                 <a:spcPts val="800"/>
               </a:spcAft>
-              <a:defRPr sz="1900">
+              <a:defRPr sz="1650">
                 <a:solidFill>
                   <a:srgbClr val="1B1F23"/>
                 </a:solidFill>
@@ -3911,7 +3935,7 @@
               <a:spcAft>
                 <a:spcPts val="800"/>
               </a:spcAft>
-              <a:defRPr sz="1900">
+              <a:defRPr sz="1650">
                 <a:solidFill>
                   <a:srgbClr val="1B1F23"/>
                 </a:solidFill>
@@ -3924,9 +3948,33 @@
           </a:p>
         </p:txBody>
       </p:sp>
-      <p:sp>
-        <p:nvSpPr>
-          <p:cNvPr id="6" name="TextBox 5"/>
+      <p:pic>
+        <p:nvPicPr>
+          <p:cNvPr id="6" name="Picture 5" descr="dwb_dynamic_window.png"/>
+          <p:cNvPicPr>
+            <a:picLocks noChangeAspect="1"/>
+          </p:cNvPicPr>
+          <p:nvPr/>
+        </p:nvPicPr>
+        <p:blipFill>
+          <a:blip r:embed="rId2"/>
+          <a:stretch>
+            <a:fillRect/>
+          </a:stretch>
+        </p:blipFill>
+        <p:spPr>
+          <a:xfrm>
+            <a:off x="5394960" y="2591399"/>
+            <a:ext cx="6126480" cy="2543880"/>
+          </a:xfrm>
+          <a:prstGeom prst="rect">
+            <a:avLst/>
+          </a:prstGeom>
+        </p:spPr>
+      </p:pic>
+      <p:sp>
+        <p:nvSpPr>
+          <p:cNvPr id="7" name="TextBox 6"/>
           <p:cNvSpPr txBox="1"/>
           <p:nvPr/>
         </p:nvSpPr>
@@ -3962,7 +4010,7 @@
       </p:sp>
       <p:sp>
         <p:nvSpPr>
-          <p:cNvPr id="7" name="TextBox 6"/>
+          <p:cNvPr id="8" name="TextBox 7"/>
           <p:cNvSpPr txBox="1"/>
           <p:nvPr/>
         </p:nvSpPr>
@@ -4733,7 +4781,7 @@
               </a:defRPr>
             </a:pPr>
             <a:r>
-              <a:t>Behavior Cloning 与两轮 DAgger</a:t>
+              <a:t>Behavior Cloning：先学习专家映射</a:t>
             </a:r>
           </a:p>
         </p:txBody>
@@ -4812,7 +4860,7 @@
               </a:defRPr>
             </a:pPr>
             <a:r>
-              <a:t>DAgger 专门补充当前策略会访问、原始示范不足的恢复状态</a:t>
+              <a:t>BC 在专家数据分布上拟合 25 类动作，但不会主动看见自身错误后的状态</a:t>
             </a:r>
           </a:p>
         </p:txBody>
@@ -4825,25 +4873,25 @@
         </p:nvSpPr>
         <p:spPr>
           <a:xfrm>
-            <a:off x="914400" y="1719072"/>
-            <a:ext cx="10241280" cy="4389120"/>
-          </a:xfrm>
-          <a:prstGeom prst="rect">
-            <a:avLst/>
-          </a:prstGeom>
-          <a:noFill/>
-        </p:spPr>
-        <p:txBody>
-          <a:bodyPr wrap="square">
-            <a:spAutoFit/>
-          </a:bodyPr>
-          <a:lstStyle/>
-          <a:p>
-            <a:pPr>
-              <a:spcAft>
-                <a:spcPts val="800"/>
-              </a:spcAft>
-              <a:defRPr sz="1900">
+            <a:off x="685800" y="1691640"/>
+            <a:ext cx="4572000" cy="4389120"/>
+          </a:xfrm>
+          <a:prstGeom prst="rect">
+            <a:avLst/>
+          </a:prstGeom>
+          <a:noFill/>
+        </p:spPr>
+        <p:txBody>
+          <a:bodyPr wrap="square">
+            <a:spAutoFit/>
+          </a:bodyPr>
+          <a:lstStyle/>
+          <a:p>
+            <a:pPr>
+              <a:spcAft>
+                <a:spcPts val="800"/>
+              </a:spcAft>
+              <a:defRPr sz="1650">
                 <a:solidFill>
                   <a:srgbClr val="1B1F23"/>
                 </a:solidFill>
@@ -4859,70 +4907,94 @@
               <a:spcAft>
                 <a:spcPts val="800"/>
               </a:spcAft>
-              <a:defRPr sz="1900">
-                <a:solidFill>
-                  <a:srgbClr val="1B1F23"/>
-                </a:solidFill>
-                <a:latin typeface="Noto Sans CJK SC"/>
-              </a:defRPr>
-            </a:pPr>
-            <a:r>
-              <a:t>• 训练先完成 Uniform BC</a:t>
-            </a:r>
-          </a:p>
-          <a:p>
-            <a:pPr>
-              <a:spcAft>
-                <a:spcPts val="800"/>
-              </a:spcAft>
-              <a:defRPr sz="1900">
-                <a:solidFill>
-                  <a:srgbClr val="1B1F23"/>
-                </a:solidFill>
-                <a:latin typeface="Noto Sans CJK SC"/>
-              </a:defRPr>
-            </a:pPr>
-            <a:r>
-              <a:t>• 每轮在 train split 闭环运行并由专家重新标注</a:t>
-            </a:r>
-          </a:p>
-          <a:p>
-            <a:pPr>
-              <a:spcAft>
-                <a:spcPts val="800"/>
-              </a:spcAft>
-              <a:defRPr sz="1900">
-                <a:solidFill>
-                  <a:srgbClr val="1B1F23"/>
-                </a:solidFill>
-                <a:latin typeface="Noto Sans CJK SC"/>
-              </a:defRPr>
-            </a:pPr>
-            <a:r>
-              <a:t>• 聚合数据后只在固定 validation 上选择 checkpoint</a:t>
-            </a:r>
-          </a:p>
-          <a:p>
-            <a:pPr>
-              <a:spcAft>
-                <a:spcPts val="800"/>
-              </a:spcAft>
-              <a:defRPr sz="1900">
-                <a:solidFill>
-                  <a:srgbClr val="1B1F23"/>
-                </a:solidFill>
-                <a:latin typeface="Noto Sans CJK SC"/>
-              </a:defRPr>
-            </a:pPr>
-            <a:r>
-              <a:t>• 未选中的第二轮候选和 margin 负面结果继续保留</a:t>
-            </a:r>
-          </a:p>
-        </p:txBody>
-      </p:sp>
-      <p:sp>
-        <p:nvSpPr>
-          <p:cNvPr id="6" name="TextBox 5"/>
+              <a:defRPr sz="1650">
+                <a:solidFill>
+                  <a:srgbClr val="1B1F23"/>
+                </a:solidFill>
+                <a:latin typeface="Noto Sans CJK SC"/>
+              </a:defRPr>
+            </a:pPr>
+            <a:r>
+              <a:t>• 监督目标来自特权专家在合法动作集合中的选择</a:t>
+            </a:r>
+          </a:p>
+          <a:p>
+            <a:pPr>
+              <a:spcAft>
+                <a:spcPts val="800"/>
+              </a:spcAft>
+              <a:defRPr sz="1650">
+                <a:solidFill>
+                  <a:srgbClr val="1B1F23"/>
+                </a:solidFill>
+                <a:latin typeface="Noto Sans CJK SC"/>
+              </a:defRPr>
+            </a:pPr>
+            <a:r>
+              <a:t>• Uniform BC 是相同观测、动作和 mask 下的直接对照</a:t>
+            </a:r>
+          </a:p>
+          <a:p>
+            <a:pPr>
+              <a:spcAft>
+                <a:spcPts val="800"/>
+              </a:spcAft>
+              <a:defRPr sz="1650">
+                <a:solidFill>
+                  <a:srgbClr val="1B1F23"/>
+                </a:solidFill>
+                <a:latin typeface="Noto Sans CJK SC"/>
+              </a:defRPr>
+            </a:pPr>
+            <a:r>
+              <a:t>• 一次小错误会改变后续观测，产生训练时稀少的恢复状态</a:t>
+            </a:r>
+          </a:p>
+          <a:p>
+            <a:pPr>
+              <a:spcAft>
+                <a:spcPts val="800"/>
+              </a:spcAft>
+              <a:defRPr sz="1650">
+                <a:solidFill>
+                  <a:srgbClr val="1B1F23"/>
+                </a:solidFill>
+                <a:latin typeface="Noto Sans CJK SC"/>
+              </a:defRPr>
+            </a:pPr>
+            <a:r>
+              <a:t>• 因此离线 top-1 accuracy 不能替代闭环评估</a:t>
+            </a:r>
+          </a:p>
+        </p:txBody>
+      </p:sp>
+      <p:pic>
+        <p:nvPicPr>
+          <p:cNvPr id="6" name="Picture 5" descr="bc_distribution_shift.png"/>
+          <p:cNvPicPr>
+            <a:picLocks noChangeAspect="1"/>
+          </p:cNvPicPr>
+          <p:nvPr/>
+        </p:nvPicPr>
+        <p:blipFill>
+          <a:blip r:embed="rId2"/>
+          <a:stretch>
+            <a:fillRect/>
+          </a:stretch>
+        </p:blipFill>
+        <p:spPr>
+          <a:xfrm>
+            <a:off x="5394960" y="2491329"/>
+            <a:ext cx="6126480" cy="2744020"/>
+          </a:xfrm>
+          <a:prstGeom prst="rect">
+            <a:avLst/>
+          </a:prstGeom>
+        </p:spPr>
+      </p:pic>
+      <p:sp>
+        <p:nvSpPr>
+          <p:cNvPr id="7" name="TextBox 6"/>
           <p:cNvSpPr txBox="1"/>
           <p:nvPr/>
         </p:nvSpPr>
@@ -4958,7 +5030,7 @@
       </p:sp>
       <p:sp>
         <p:nvSpPr>
-          <p:cNvPr id="7" name="TextBox 6"/>
+          <p:cNvPr id="8" name="TextBox 7"/>
           <p:cNvSpPr txBox="1"/>
           <p:nvPr/>
         </p:nvSpPr>
@@ -5049,7 +5121,7 @@
               </a:defRPr>
             </a:pPr>
             <a:r>
-              <a:t>训练—部署信息隔离</a:t>
+              <a:t>BC 的误差为什么会在闭环累积？</a:t>
             </a:r>
           </a:p>
         </p:txBody>
@@ -5128,7 +5200,7 @@
               </a:defRPr>
             </a:pPr>
             <a:r>
-              <a:t>强监督可以来自仿真真值，但部署接口必须保持可观测</a:t>
+              <a:t>策略一旦偏离专家轨迹，后续输入不再服从原始示范分布</a:t>
             </a:r>
           </a:p>
         </p:txBody>
@@ -5167,7 +5239,7 @@
               </a:defRPr>
             </a:pPr>
             <a:r>
-              <a:t>• privileged humans / future outcomes 只存在数据与专家侧</a:t>
+              <a:t>• 专家数据主要覆盖理想恢复路径附近的状态</a:t>
             </a:r>
           </a:p>
           <a:p>
@@ -5183,7 +5255,7 @@
               </a:defRPr>
             </a:pPr>
             <a:r>
-              <a:t>• 导出模型不包含真值行人张量</a:t>
+              <a:t>• 学习器的早期误差会把机器人带入未覆盖区域</a:t>
             </a:r>
           </a:p>
           <a:p>
@@ -5199,7 +5271,7 @@
               </a:defRPr>
             </a:pPr>
             <a:r>
-              <a:t>• ROS 推理节点只接收标准化正式观测和 mask</a:t>
+              <a:t>• 未覆盖区域上预测更差，继续放大轨迹偏差</a:t>
             </a:r>
           </a:p>
           <a:p>
@@ -5215,14 +5287,30 @@
               </a:defRPr>
             </a:pPr>
             <a:r>
-              <a:t>• schema、checkpoint manifest 与接口测试共同检查泄漏</a:t>
+              <a:t>• 恢复任务尤其容易出现 WAIT、BACKUP 或左右切换循环</a:t>
+            </a:r>
+          </a:p>
+          <a:p>
+            <a:pPr>
+              <a:spcAft>
+                <a:spcPts val="800"/>
+              </a:spcAft>
+              <a:defRPr sz="1650">
+                <a:solidFill>
+                  <a:srgbClr val="1B1F23"/>
+                </a:solidFill>
+                <a:latin typeface="Noto Sans CJK SC"/>
+              </a:defRPr>
+            </a:pPr>
+            <a:r>
+              <a:t>• 需要在学习器真正访问的状态上重新询问专家</a:t>
             </a:r>
           </a:p>
         </p:txBody>
       </p:sp>
       <p:pic>
         <p:nvPicPr>
-          <p:cNvPr id="6" name="Picture 5" descr="system_architecture.png"/>
+          <p:cNvPr id="6" name="Picture 5" descr="bc_distribution_shift.png"/>
           <p:cNvPicPr>
             <a:picLocks noChangeAspect="1"/>
           </p:cNvPicPr>
@@ -5236,8 +5324,8 @@
         </p:blipFill>
         <p:spPr>
           <a:xfrm>
-            <a:off x="5394960" y="2458410"/>
-            <a:ext cx="6126480" cy="2809858"/>
+            <a:off x="5394960" y="2491329"/>
+            <a:ext cx="6126480" cy="2744020"/>
           </a:xfrm>
           <a:prstGeom prst="rect">
             <a:avLst/>
@@ -5373,7 +5461,7 @@
               </a:defRPr>
             </a:pPr>
             <a:r>
-              <a:t>真实 Arena/Gazebo 运行证据</a:t>
+              <a:t>DAgger：在学习器访问的状态上询问专家</a:t>
             </a:r>
           </a:p>
         </p:txBody>
@@ -5452,7 +5540,7 @@
               </a:defRPr>
             </a:pPr>
             <a:r>
-              <a:t>不是概念图：Jackal、动态行人、静态瓶颈和 Nav2 在同一 episode 实际运行</a:t>
+              <a:t>闭环采样、专家重标、数据聚合与重新训练构成迭代分布覆盖</a:t>
             </a:r>
           </a:p>
         </p:txBody>
@@ -5491,7 +5579,7 @@
               </a:defRPr>
             </a:pPr>
             <a:r>
-              <a:t>• 环境：Ubuntu 22.04 / ROS2 Humble / Arena Gazebo</a:t>
+              <a:t>• 以当前策略在 train split 闭环运行，收集实际访问状态</a:t>
             </a:r>
           </a:p>
           <a:p>
@@ -5507,7 +5595,7 @@
               </a:defRPr>
             </a:pPr>
             <a:r>
-              <a:t>• 机器人与感知：Jackal / Nav2 DWB / 平面 LiDAR</a:t>
+              <a:t>• 特权专家为这些状态给出合法恢复动作标签</a:t>
             </a:r>
           </a:p>
           <a:p>
@@ -5523,7 +5611,7 @@
               </a:defRPr>
             </a:pPr>
             <a:r>
-              <a:t>• 冻结 v5 演示：doorway_bottleneck / medium / validation</a:t>
+              <a:t>• 把新样本并入聚合数据集，再训练下一候选策略</a:t>
             </a:r>
           </a:p>
           <a:p>
@@ -5539,7 +5627,7 @@
               </a:defRPr>
             </a:pPr>
             <a:r>
-              <a:t>• episode ID：runtime_capture_gazebo_doorway_bottleneck_medium_20260806T054015Z_3875172；pixel SHA256：5313957c3032</a:t>
+              <a:t>• 只用固定 validation 选择是否接受候选 checkpoint</a:t>
             </a:r>
           </a:p>
           <a:p>
@@ -5555,14 +5643,14 @@
               </a:defRPr>
             </a:pPr>
             <a:r>
-              <a:t>• 它不是锁定 v6 统计回合的 camera frame，也不替代定量实验</a:t>
+              <a:t>• test 在模型和协议冻结前保持关闭</a:t>
             </a:r>
           </a:p>
         </p:txBody>
       </p:sp>
       <p:pic>
         <p:nvPicPr>
-          <p:cNvPr id="6" name="Picture 5" descr="runtime_gazebo_doorway_bottleneck_medium.png"/>
+          <p:cNvPr id="6" name="Picture 5" descr="dagger_loop.png"/>
           <p:cNvPicPr>
             <a:picLocks noChangeAspect="1"/>
           </p:cNvPicPr>
@@ -5576,8 +5664,8 @@
         </p:blipFill>
         <p:spPr>
           <a:xfrm>
-            <a:off x="5779927" y="1600200"/>
-            <a:ext cx="5356544" cy="4526280"/>
+            <a:off x="5394960" y="2498863"/>
+            <a:ext cx="6126480" cy="2728953"/>
           </a:xfrm>
           <a:prstGeom prst="rect">
             <a:avLst/>
@@ -5713,7 +5801,7 @@
               </a:defRPr>
             </a:pPr>
             <a:r>
-              <a:t>八类场景 × 三档密度</a:t>
+              <a:t>PGRR 的两轮 DAgger 与模型选择</a:t>
             </a:r>
           </a:p>
         </p:txBody>
@@ -5792,7 +5880,7 @@
               </a:defRPr>
             </a:pPr>
             <a:r>
-              <a:t>从正面对向到临时封堵，覆盖不同动态交互结构</a:t>
+              <a:t>工作流完整执行两轮，但 validation 没有提升的第二候选不会进入最终模型</a:t>
             </a:r>
           </a:p>
         </p:txBody>
@@ -5831,7 +5919,7 @@
               </a:defRPr>
             </a:pPr>
             <a:r>
-              <a:t>• head-on、doorway、crossing、blind corner</a:t>
+              <a:t>• 起点：Uniform BC checkpoint 与固定训练数据</a:t>
             </a:r>
           </a:p>
           <a:p>
@@ -5847,7 +5935,7 @@
               </a:defRPr>
             </a:pPr>
             <a:r>
-              <a:t>• group blocking、overtaking、opposite streams、temporary blockage</a:t>
+              <a:t>• Round 1：闭环收集策略诱导状态，专家重标并聚合</a:t>
             </a:r>
           </a:p>
           <a:p>
@@ -5863,7 +5951,7 @@
               </a:defRPr>
             </a:pPr>
             <a:r>
-              <a:t>• 每类 low / medium / high</a:t>
+              <a:t>• Round 2：流程完成，但候选在 validation 上被拒绝</a:t>
             </a:r>
           </a:p>
           <a:p>
@@ -5879,14 +5967,30 @@
               </a:defRPr>
             </a:pPr>
             <a:r>
-              <a:t>• 地图、起终点、行人路线和 seed 写入 manifest</a:t>
+              <a:t>• 最终导出 validation 选择的 Triggered-DAgger best.onnx</a:t>
+            </a:r>
+          </a:p>
+          <a:p>
+            <a:pPr>
+              <a:spcAft>
+                <a:spcPts val="800"/>
+              </a:spcAft>
+              <a:defRPr sz="1650">
+                <a:solidFill>
+                  <a:srgbClr val="1B1F23"/>
+                </a:solidFill>
+                <a:latin typeface="Noto Sans CJK SC"/>
+              </a:defRPr>
+            </a:pPr>
+            <a:r>
+              <a:t>• margin weighting 未改善冻结离线消融，作为负面结果保留</a:t>
             </a:r>
           </a:p>
         </p:txBody>
       </p:sp>
       <p:pic>
         <p:nvPicPr>
-          <p:cNvPr id="6" name="Picture 5" descr="scenario_overview.png"/>
+          <p:cNvPr id="6" name="Picture 5" descr="pgrr_dagger_rounds.png"/>
           <p:cNvPicPr>
             <a:picLocks noChangeAspect="1"/>
           </p:cNvPicPr>
@@ -5900,8 +6004,8 @@
         </p:blipFill>
         <p:spPr>
           <a:xfrm>
-            <a:off x="5394960" y="2357609"/>
-            <a:ext cx="6126480" cy="3011461"/>
+            <a:off x="5394960" y="2498863"/>
+            <a:ext cx="6126480" cy="2728953"/>
           </a:xfrm>
           <a:prstGeom prst="rect">
             <a:avLst/>
@@ -6037,7 +6141,7 @@
               </a:defRPr>
             </a:pPr>
             <a:r>
-              <a:t>Split、规模与锁定规则</a:t>
+              <a:t>训练—部署隔离与锁定规则</a:t>
             </a:r>
           </a:p>
         </p:txBody>
@@ -6116,7 +6220,7 @@
               </a:defRPr>
             </a:pPr>
             <a:r>
-              <a:t>validation 用于选择，test 只在代码、配置和 checkpoint 冻结后打开</a:t>
+              <a:t>专家可使用仿真特权信息；部署模型只接受机器人可观测量和 planning mask</a:t>
             </a:r>
           </a:p>
         </p:txBody>
@@ -6129,89 +6233,73 @@
         </p:nvSpPr>
         <p:spPr>
           <a:xfrm>
-            <a:off x="914400" y="1719072"/>
-            <a:ext cx="10241280" cy="4389120"/>
-          </a:xfrm>
-          <a:prstGeom prst="rect">
-            <a:avLst/>
-          </a:prstGeom>
-          <a:noFill/>
-        </p:spPr>
-        <p:txBody>
-          <a:bodyPr wrap="square">
-            <a:spAutoFit/>
-          </a:bodyPr>
-          <a:lstStyle/>
-          <a:p>
-            <a:pPr>
-              <a:spcAft>
-                <a:spcPts val="800"/>
-              </a:spcAft>
-              <a:defRPr sz="1900">
-                <a:solidFill>
-                  <a:srgbClr val="1B1F23"/>
-                </a:solidFill>
-                <a:latin typeface="Noto Sans CJK SC"/>
-              </a:defRPr>
-            </a:pPr>
-            <a:r>
-              <a:t>• moderate-v6：Train / validation / test 使用不相交 seed 和 scenario ID</a:t>
-            </a:r>
-          </a:p>
-          <a:p>
-            <a:pPr>
-              <a:spcAft>
-                <a:spcPts val="800"/>
-              </a:spcAft>
-              <a:defRPr sz="1900">
-                <a:solidFill>
-                  <a:srgbClr val="1B1F23"/>
-                </a:solidFill>
-                <a:latin typeface="Noto Sans CJK SC"/>
-              </a:defRPr>
-            </a:pPr>
-            <a:r>
-              <a:t>• v5 Base validation 57/72，超过 75% ceiling，故 rejected 且 test 未打开</a:t>
-            </a:r>
-          </a:p>
-          <a:p>
-            <a:pPr>
-              <a:spcAft>
-                <a:spcPts val="800"/>
-              </a:spcAft>
-              <a:defRPr sz="1900">
-                <a:solidFill>
-                  <a:srgbClr val="1B1F23"/>
-                </a:solidFill>
-                <a:latin typeface="Noto Sans CJK SC"/>
-              </a:defRPr>
-            </a:pPr>
-            <a:r>
-              <a:t>• Validation：72 条件 × 5 方法 = 360 method-episodes</a:t>
-            </a:r>
-          </a:p>
-          <a:p>
-            <a:pPr>
-              <a:spcAft>
-                <a:spcPts val="800"/>
-              </a:spcAft>
-              <a:defRPr sz="1900">
-                <a:solidFill>
-                  <a:srgbClr val="1B1F23"/>
-                </a:solidFill>
-                <a:latin typeface="Noto Sans CJK SC"/>
-              </a:defRPr>
-            </a:pPr>
-            <a:r>
-              <a:t>• 锁定 Test：120 条件 × 5 方法 = 600 method-episodes</a:t>
-            </a:r>
-          </a:p>
-          <a:p>
-            <a:pPr>
-              <a:spcAft>
-                <a:spcPts val="800"/>
-              </a:spcAft>
-              <a:defRPr sz="1900">
+            <a:off x="685800" y="1691640"/>
+            <a:ext cx="4572000" cy="4389120"/>
+          </a:xfrm>
+          <a:prstGeom prst="rect">
+            <a:avLst/>
+          </a:prstGeom>
+          <a:noFill/>
+        </p:spPr>
+        <p:txBody>
+          <a:bodyPr wrap="square">
+            <a:spAutoFit/>
+          </a:bodyPr>
+          <a:lstStyle/>
+          <a:p>
+            <a:pPr>
+              <a:spcAft>
+                <a:spcPts val="800"/>
+              </a:spcAft>
+              <a:defRPr sz="1650">
+                <a:solidFill>
+                  <a:srgbClr val="1B1F23"/>
+                </a:solidFill>
+                <a:latin typeface="Noto Sans CJK SC"/>
+              </a:defRPr>
+            </a:pPr>
+            <a:r>
+              <a:t>• 训练侧：行人真值与短时未来只用于专家 rollout 标签</a:t>
+            </a:r>
+          </a:p>
+          <a:p>
+            <a:pPr>
+              <a:spcAft>
+                <a:spcPts val="800"/>
+              </a:spcAft>
+              <a:defRPr sz="1650">
+                <a:solidFill>
+                  <a:srgbClr val="1B1F23"/>
+                </a:solidFill>
+                <a:latin typeface="Noto Sans CJK SC"/>
+              </a:defRPr>
+            </a:pPr>
+            <a:r>
+              <a:t>• 部署侧：LiDAR、目标、局部路径、速度、进展与 planner 状态</a:t>
+            </a:r>
+          </a:p>
+          <a:p>
+            <a:pPr>
+              <a:spcAft>
+                <a:spcPts val="800"/>
+              </a:spcAft>
+              <a:defRPr sz="1650">
+                <a:solidFill>
+                  <a:srgbClr val="1B1F23"/>
+                </a:solidFill>
+                <a:latin typeface="Noto Sans CJK SC"/>
+              </a:defRPr>
+            </a:pPr>
+            <a:r>
+              <a:t>• Train / validation / test 按 scenario 与 map 分离，不按 frame</a:t>
+            </a:r>
+          </a:p>
+          <a:p>
+            <a:pPr>
+              <a:spcAft>
+                <a:spcPts val="800"/>
+              </a:spcAft>
+              <a:defRPr sz="1650">
                 <a:solidFill>
                   <a:srgbClr val="1B1F23"/>
                 </a:solidFill>
@@ -6227,22 +6315,46 @@
               <a:spcAft>
                 <a:spcPts val="800"/>
               </a:spcAft>
-              <a:defRPr sz="1900">
-                <a:solidFill>
-                  <a:srgbClr val="1B1F23"/>
-                </a:solidFill>
-                <a:latin typeface="Noto Sans CJK SC"/>
-              </a:defRPr>
-            </a:pPr>
-            <a:r>
-              <a:t>• test 结果不能反向调参</a:t>
-            </a:r>
-          </a:p>
-        </p:txBody>
-      </p:sp>
-      <p:sp>
-        <p:nvSpPr>
-          <p:cNvPr id="6" name="TextBox 5"/>
+              <a:defRPr sz="1650">
+                <a:solidFill>
+                  <a:srgbClr val="1B1F23"/>
+                </a:solidFill>
+                <a:latin typeface="Noto Sans CJK SC"/>
+              </a:defRPr>
+            </a:pPr>
+            <a:r>
+              <a:t>• checkpoint、代码与协议冻结后才打开 120 条件 test</a:t>
+            </a:r>
+          </a:p>
+        </p:txBody>
+      </p:sp>
+      <p:pic>
+        <p:nvPicPr>
+          <p:cNvPr id="6" name="Picture 5" descr="pgrr_dagger_rounds.png"/>
+          <p:cNvPicPr>
+            <a:picLocks noChangeAspect="1"/>
+          </p:cNvPicPr>
+          <p:nvPr/>
+        </p:nvPicPr>
+        <p:blipFill>
+          <a:blip r:embed="rId2"/>
+          <a:stretch>
+            <a:fillRect/>
+          </a:stretch>
+        </p:blipFill>
+        <p:spPr>
+          <a:xfrm>
+            <a:off x="5394960" y="2498863"/>
+            <a:ext cx="6126480" cy="2728953"/>
+          </a:xfrm>
+          <a:prstGeom prst="rect">
+            <a:avLst/>
+          </a:prstGeom>
+        </p:spPr>
+      </p:pic>
+      <p:sp>
+        <p:nvSpPr>
+          <p:cNvPr id="7" name="TextBox 6"/>
           <p:cNvSpPr txBox="1"/>
           <p:nvPr/>
         </p:nvSpPr>
@@ -6278,7 +6390,7 @@
       </p:sp>
       <p:sp>
         <p:nvSpPr>
-          <p:cNvPr id="7" name="TextBox 6"/>
+          <p:cNvPr id="8" name="TextBox 7"/>
           <p:cNvSpPr txBox="1"/>
           <p:nvPr/>
         </p:nvSpPr>
@@ -6369,7 +6481,7 @@
               </a:defRPr>
             </a:pPr>
             <a:r>
-              <a:t>五种闭环对比方法</a:t>
+              <a:t>真实 Arena/Gazebo 运行环境</a:t>
             </a:r>
           </a:p>
         </p:txBody>
@@ -6448,7 +6560,7 @@
               </a:defRPr>
             </a:pPr>
             <a:r>
-              <a:t>从纯经典基线到训练分布聚合，逐级增加恢复能力</a:t>
+              <a:t>不是示意图：Jackal、动态行人、静态瓶颈与 Nav2 DWB 在同一 episode 运行</a:t>
             </a:r>
           </a:p>
         </p:txBody>
@@ -6461,104 +6573,128 @@
         </p:nvSpPr>
         <p:spPr>
           <a:xfrm>
-            <a:off x="914400" y="1719072"/>
-            <a:ext cx="10241280" cy="4389120"/>
-          </a:xfrm>
-          <a:prstGeom prst="rect">
-            <a:avLst/>
-          </a:prstGeom>
-          <a:noFill/>
-        </p:spPr>
-        <p:txBody>
-          <a:bodyPr wrap="square">
-            <a:spAutoFit/>
-          </a:bodyPr>
-          <a:lstStyle/>
-          <a:p>
-            <a:pPr>
-              <a:spcAft>
-                <a:spcPts val="800"/>
-              </a:spcAft>
-              <a:defRPr sz="1900">
-                <a:solidFill>
-                  <a:srgbClr val="1B1F23"/>
-                </a:solidFill>
-                <a:latin typeface="Noto Sans CJK SC"/>
-              </a:defRPr>
-            </a:pPr>
-            <a:r>
-              <a:t>• DWB：无 PGRR 恢复层</a:t>
-            </a:r>
-          </a:p>
-          <a:p>
-            <a:pPr>
-              <a:spcAft>
-                <a:spcPts val="800"/>
-              </a:spcAft>
-              <a:defRPr sz="1900">
-                <a:solidFill>
-                  <a:srgbClr val="1B1F23"/>
-                </a:solidFill>
-                <a:latin typeface="Noto Sans CJK SC"/>
-              </a:defRPr>
-            </a:pPr>
-            <a:r>
-              <a:t>• Standard：导航栈标准恢复</a:t>
-            </a:r>
-          </a:p>
-          <a:p>
-            <a:pPr>
-              <a:spcAft>
-                <a:spcPts val="800"/>
-              </a:spcAft>
-              <a:defRPr sz="1900">
-                <a:solidFill>
-                  <a:srgbClr val="1B1F23"/>
-                </a:solidFill>
-                <a:latin typeface="Noto Sans CJK SC"/>
-              </a:defRPr>
-            </a:pPr>
-            <a:r>
-              <a:t>• Heuristic：规则触发 + 手工动作</a:t>
-            </a:r>
-          </a:p>
-          <a:p>
-            <a:pPr>
-              <a:spcAft>
-                <a:spcPts val="800"/>
-              </a:spcAft>
-              <a:defRPr sz="1900">
-                <a:solidFill>
-                  <a:srgbClr val="1B1F23"/>
-                </a:solidFill>
-                <a:latin typeface="Noto Sans CJK SC"/>
-              </a:defRPr>
-            </a:pPr>
-            <a:r>
-              <a:t>• Uniform BC：相同观测、动作和 mask 的行为克隆</a:t>
-            </a:r>
-          </a:p>
-          <a:p>
-            <a:pPr>
-              <a:spcAft>
-                <a:spcPts val="800"/>
-              </a:spcAft>
-              <a:defRPr sz="1900">
-                <a:solidFill>
-                  <a:srgbClr val="1B1F23"/>
-                </a:solidFill>
-                <a:latin typeface="Noto Sans CJK SC"/>
-              </a:defRPr>
-            </a:pPr>
-            <a:r>
-              <a:t>• PGRR：选定 DAgger checkpoint + 有界恢复闭环</a:t>
-            </a:r>
-          </a:p>
-        </p:txBody>
-      </p:sp>
-      <p:sp>
-        <p:nvSpPr>
-          <p:cNvPr id="6" name="TextBox 5"/>
+            <a:off x="685800" y="1691640"/>
+            <a:ext cx="4572000" cy="4389120"/>
+          </a:xfrm>
+          <a:prstGeom prst="rect">
+            <a:avLst/>
+          </a:prstGeom>
+          <a:noFill/>
+        </p:spPr>
+        <p:txBody>
+          <a:bodyPr wrap="square">
+            <a:spAutoFit/>
+          </a:bodyPr>
+          <a:lstStyle/>
+          <a:p>
+            <a:pPr>
+              <a:spcAft>
+                <a:spcPts val="800"/>
+              </a:spcAft>
+              <a:defRPr sz="1650">
+                <a:solidFill>
+                  <a:srgbClr val="1B1F23"/>
+                </a:solidFill>
+                <a:latin typeface="Noto Sans CJK SC"/>
+              </a:defRPr>
+            </a:pPr>
+            <a:r>
+              <a:t>• Ubuntu 22.04 / ROS2 Humble / Arena Gazebo</a:t>
+            </a:r>
+          </a:p>
+          <a:p>
+            <a:pPr>
+              <a:spcAft>
+                <a:spcPts val="800"/>
+              </a:spcAft>
+              <a:defRPr sz="1650">
+                <a:solidFill>
+                  <a:srgbClr val="1B1F23"/>
+                </a:solidFill>
+                <a:latin typeface="Noto Sans CJK SC"/>
+              </a:defRPr>
+            </a:pPr>
+            <a:r>
+              <a:t>• Jackal / Nav2 DWB / 平面 LiDAR / 动态代理</a:t>
+            </a:r>
+          </a:p>
+          <a:p>
+            <a:pPr>
+              <a:spcAft>
+                <a:spcPts val="800"/>
+              </a:spcAft>
+              <a:defRPr sz="1650">
+                <a:solidFill>
+                  <a:srgbClr val="1B1F23"/>
+                </a:solidFill>
+                <a:latin typeface="Noto Sans CJK SC"/>
+              </a:defRPr>
+            </a:pPr>
+            <a:r>
+              <a:t>• 历史 moderate-v5 validation 环境演示（不是另一当前版本）</a:t>
+            </a:r>
+          </a:p>
+          <a:p>
+            <a:pPr>
+              <a:spcAft>
+                <a:spcPts val="800"/>
+              </a:spcAft>
+              <a:defRPr sz="1650">
+                <a:solidFill>
+                  <a:srgbClr val="1B1F23"/>
+                </a:solidFill>
+                <a:latin typeface="Noto Sans CJK SC"/>
+              </a:defRPr>
+            </a:pPr>
+            <a:r>
+              <a:t>• episode ID：runtime_capture_gazebo_doorway_bottleneck_medium_20260806T054015Z_3875172；pixel SHA256：5313957c3032</a:t>
+            </a:r>
+          </a:p>
+          <a:p>
+            <a:pPr>
+              <a:spcAft>
+                <a:spcPts val="800"/>
+              </a:spcAft>
+              <a:defRPr sz="1650">
+                <a:solidFill>
+                  <a:srgbClr val="1B1F23"/>
+                </a:solidFill>
+                <a:latin typeface="Noto Sans CJK SC"/>
+              </a:defRPr>
+            </a:pPr>
+            <a:r>
+              <a:t>• 截图仅证明真实运行环境，不替代锁定 test 的总体统计</a:t>
+            </a:r>
+          </a:p>
+        </p:txBody>
+      </p:sp>
+      <p:pic>
+        <p:nvPicPr>
+          <p:cNvPr id="6" name="Picture 5" descr="runtime_gazebo_doorway_bottleneck_medium.png"/>
+          <p:cNvPicPr>
+            <a:picLocks noChangeAspect="1"/>
+          </p:cNvPicPr>
+          <p:nvPr/>
+        </p:nvPicPr>
+        <p:blipFill>
+          <a:blip r:embed="rId2"/>
+          <a:stretch>
+            <a:fillRect/>
+          </a:stretch>
+        </p:blipFill>
+        <p:spPr>
+          <a:xfrm>
+            <a:off x="5779927" y="1600200"/>
+            <a:ext cx="5356544" cy="4526280"/>
+          </a:xfrm>
+          <a:prstGeom prst="rect">
+            <a:avLst/>
+          </a:prstGeom>
+        </p:spPr>
+      </p:pic>
+      <p:sp>
+        <p:nvSpPr>
+          <p:cNvPr id="7" name="TextBox 6"/>
           <p:cNvSpPr txBox="1"/>
           <p:nvPr/>
         </p:nvSpPr>
@@ -6594,7 +6730,7 @@
       </p:sp>
       <p:sp>
         <p:nvSpPr>
-          <p:cNvPr id="7" name="TextBox 6"/>
+          <p:cNvPr id="8" name="TextBox 7"/>
           <p:cNvSpPr txBox="1"/>
           <p:nvPr/>
         </p:nvSpPr>
@@ -7001,7 +7137,7 @@
               </a:defRPr>
             </a:pPr>
             <a:r>
-              <a:t>指标与统计协议</a:t>
+              <a:t>五方法、同条件、完整证据链</a:t>
             </a:r>
           </a:p>
         </p:txBody>
@@ -7080,7 +7216,7 @@
               </a:defRPr>
             </a:pPr>
             <a:r>
-              <a:t>一个方法不能靠永远 WAIT 获得虚假安全优势</a:t>
+              <a:t>从 Base DWB 到 PGRR，五种方法共享 120 个锁定条件并保留全部终局</a:t>
             </a:r>
           </a:p>
         </p:txBody>
@@ -7093,105 +7229,105 @@
         </p:nvSpPr>
         <p:spPr>
           <a:xfrm>
-            <a:off x="914400" y="1719072"/>
-            <a:ext cx="10241280" cy="4389120"/>
-          </a:xfrm>
-          <a:prstGeom prst="rect">
-            <a:avLst/>
-          </a:prstGeom>
-          <a:noFill/>
-        </p:spPr>
-        <p:txBody>
-          <a:bodyPr wrap="square">
-            <a:spAutoFit/>
-          </a:bodyPr>
-          <a:lstStyle/>
-          <a:p>
-            <a:pPr>
-              <a:spcAft>
-                <a:spcPts val="800"/>
-              </a:spcAft>
-              <a:defRPr sz="1900">
-                <a:solidFill>
-                  <a:srgbClr val="1B1F23"/>
-                </a:solidFill>
-                <a:latin typeface="Noto Sans CJK SC"/>
-              </a:defRPr>
-            </a:pPr>
-            <a:r>
-              <a:t>• 终止：到达、碰撞、超时、规划失败</a:t>
-            </a:r>
-          </a:p>
-          <a:p>
-            <a:pPr>
-              <a:spcAft>
-                <a:spcPts val="800"/>
-              </a:spcAft>
-              <a:defRPr sz="1900">
-                <a:solidFill>
-                  <a:srgbClr val="1B1F23"/>
-                </a:solidFill>
-                <a:latin typeface="Noto Sans CJK SC"/>
-              </a:defRPr>
-            </a:pPr>
-            <a:r>
-              <a:t>• 效率：SPL、路径长度、导航时间</a:t>
-            </a:r>
-          </a:p>
-          <a:p>
-            <a:pPr>
-              <a:spcAft>
-                <a:spcPts val="800"/>
-              </a:spcAft>
-              <a:defRPr sz="1900">
-                <a:solidFill>
-                  <a:srgbClr val="1B1F23"/>
-                </a:solidFill>
-                <a:latin typeface="Noto Sans CJK SC"/>
-              </a:defRPr>
-            </a:pPr>
-            <a:r>
-              <a:t>• 安全：最小人距、个人空间侵入、不舒适时间、紧急停止</a:t>
-            </a:r>
-          </a:p>
-          <a:p>
-            <a:pPr>
-              <a:spcAft>
-                <a:spcPts val="800"/>
-              </a:spcAft>
-              <a:defRPr sz="1900">
-                <a:solidFill>
-                  <a:srgbClr val="1B1F23"/>
-                </a:solidFill>
-                <a:latin typeface="Noto Sans CJK SC"/>
-              </a:defRPr>
-            </a:pPr>
-            <a:r>
-              <a:t>• 恢复：触发、重接成功、持续时间、介入比例</a:t>
-            </a:r>
-          </a:p>
-          <a:p>
-            <a:pPr>
-              <a:spcAft>
-                <a:spcPts val="800"/>
-              </a:spcAft>
-              <a:defRPr sz="1900">
-                <a:solidFill>
-                  <a:srgbClr val="1B1F23"/>
-                </a:solidFill>
-                <a:latin typeface="Noto Sans CJK SC"/>
-              </a:defRPr>
-            </a:pPr>
-            <a:r>
-              <a:t>• 到达/碰撞/超时：McNemar；连续端点：Wilcoxon + 全局 Holm</a:t>
-            </a:r>
-          </a:p>
-          <a:p>
-            <a:pPr>
-              <a:spcAft>
-                <a:spcPts val="800"/>
-              </a:spcAft>
-              <a:defRPr sz="1900">
+            <a:off x="685800" y="1691640"/>
+            <a:ext cx="4572000" cy="4389120"/>
+          </a:xfrm>
+          <a:prstGeom prst="rect">
+            <a:avLst/>
+          </a:prstGeom>
+          <a:noFill/>
+        </p:spPr>
+        <p:txBody>
+          <a:bodyPr wrap="square">
+            <a:spAutoFit/>
+          </a:bodyPr>
+          <a:lstStyle/>
+          <a:p>
+            <a:pPr>
+              <a:spcAft>
+                <a:spcPts val="800"/>
+              </a:spcAft>
+              <a:defRPr sz="1650">
+                <a:solidFill>
+                  <a:srgbClr val="1B1F23"/>
+                </a:solidFill>
+                <a:latin typeface="Noto Sans CJK SC"/>
+              </a:defRPr>
+            </a:pPr>
+            <a:r>
+              <a:t>• Base、Standard、Heuristic、Uniform BC、PGRR 各 120 回合</a:t>
+            </a:r>
+          </a:p>
+          <a:p>
+            <a:pPr>
+              <a:spcAft>
+                <a:spcPts val="800"/>
+              </a:spcAft>
+              <a:defRPr sz="1650">
+                <a:solidFill>
+                  <a:srgbClr val="1B1F23"/>
+                </a:solidFill>
+                <a:latin typeface="Noto Sans CJK SC"/>
+              </a:defRPr>
+            </a:pPr>
+            <a:r>
+              <a:t>• 八个 family × 三档 density × 五次重复，共 600 logical episodes</a:t>
+            </a:r>
+          </a:p>
+          <a:p>
+            <a:pPr>
+              <a:spcAft>
+                <a:spcPts val="800"/>
+              </a:spcAft>
+              <a:defRPr sz="1650">
+                <a:solidFill>
+                  <a:srgbClr val="1B1F23"/>
+                </a:solidFill>
+                <a:latin typeface="Noto Sans CJK SC"/>
+              </a:defRPr>
+            </a:pPr>
+            <a:r>
+              <a:t>• 终局：到达、碰撞、超时、规划失败；基础设施失败另列</a:t>
+            </a:r>
+          </a:p>
+          <a:p>
+            <a:pPr>
+              <a:spcAft>
+                <a:spcPts val="800"/>
+              </a:spcAft>
+              <a:defRPr sz="1650">
+                <a:solidFill>
+                  <a:srgbClr val="1B1F23"/>
+                </a:solidFill>
+                <a:latin typeface="Noto Sans CJK SC"/>
+              </a:defRPr>
+            </a:pPr>
+            <a:r>
+              <a:t>• 到达/碰撞/超时做配对 McNemar，并进行全局 Holm 校正</a:t>
+            </a:r>
+          </a:p>
+          <a:p>
+            <a:pPr>
+              <a:spcAft>
+                <a:spcPts val="800"/>
+              </a:spcAft>
+              <a:defRPr sz="1650">
+                <a:solidFill>
+                  <a:srgbClr val="1B1F23"/>
+                </a:solidFill>
+                <a:latin typeface="Noto Sans CJK SC"/>
+              </a:defRPr>
+            </a:pPr>
+            <a:r>
+              <a:t>• 共同成功效率只在双方都到达的 pair 内比较</a:t>
+            </a:r>
+          </a:p>
+          <a:p>
+            <a:pPr>
+              <a:spcAft>
+                <a:spcPts val="800"/>
+              </a:spcAft>
+              <a:defRPr sz="1650">
                 <a:solidFill>
                   <a:srgbClr val="1B1F23"/>
                 </a:solidFill>
@@ -7204,9 +7340,33 @@
           </a:p>
         </p:txBody>
       </p:sp>
-      <p:sp>
-        <p:nvSpPr>
-          <p:cNvPr id="6" name="TextBox 5"/>
+      <p:pic>
+        <p:nvPicPr>
+          <p:cNvPr id="6" name="Picture 5" descr="evaluation_evidence_chain.png"/>
+          <p:cNvPicPr>
+            <a:picLocks noChangeAspect="1"/>
+          </p:cNvPicPr>
+          <p:nvPr/>
+        </p:nvPicPr>
+        <p:blipFill>
+          <a:blip r:embed="rId2"/>
+          <a:stretch>
+            <a:fillRect/>
+          </a:stretch>
+        </p:blipFill>
+        <p:spPr>
+          <a:xfrm>
+            <a:off x="5394960" y="2654068"/>
+            <a:ext cx="6126480" cy="2418543"/>
+          </a:xfrm>
+          <a:prstGeom prst="rect">
+            <a:avLst/>
+          </a:prstGeom>
+        </p:spPr>
+      </p:pic>
+      <p:sp>
+        <p:nvSpPr>
+          <p:cNvPr id="7" name="TextBox 6"/>
           <p:cNvSpPr txBox="1"/>
           <p:nvPr/>
         </p:nvSpPr>
@@ -7242,7 +7402,7 @@
       </p:sp>
       <p:sp>
         <p:nvSpPr>
-          <p:cNvPr id="7" name="TextBox 6"/>
+          <p:cNvPr id="8" name="TextBox 7"/>
           <p:cNvSpPr txBox="1"/>
           <p:nvPr/>
         </p:nvSpPr>
@@ -10026,25 +10186,25 @@
         </p:nvSpPr>
         <p:spPr>
           <a:xfrm>
-            <a:off x="914400" y="1719072"/>
-            <a:ext cx="10241280" cy="4389120"/>
-          </a:xfrm>
-          <a:prstGeom prst="rect">
-            <a:avLst/>
-          </a:prstGeom>
-          <a:noFill/>
-        </p:spPr>
-        <p:txBody>
-          <a:bodyPr wrap="square">
-            <a:spAutoFit/>
-          </a:bodyPr>
-          <a:lstStyle/>
-          <a:p>
-            <a:pPr>
-              <a:spcAft>
-                <a:spcPts val="800"/>
-              </a:spcAft>
-              <a:defRPr sz="1900">
+            <a:off x="685800" y="1691640"/>
+            <a:ext cx="4572000" cy="4389120"/>
+          </a:xfrm>
+          <a:prstGeom prst="rect">
+            <a:avLst/>
+          </a:prstGeom>
+          <a:noFill/>
+        </p:spPr>
+        <p:txBody>
+          <a:bodyPr wrap="square">
+            <a:spAutoFit/>
+          </a:bodyPr>
+          <a:lstStyle/>
+          <a:p>
+            <a:pPr>
+              <a:spcAft>
+                <a:spcPts val="800"/>
+              </a:spcAft>
+              <a:defRPr sz="1650">
                 <a:solidFill>
                   <a:srgbClr val="1B1F23"/>
                 </a:solidFill>
@@ -10060,7 +10220,7 @@
               <a:spcAft>
                 <a:spcPts val="800"/>
               </a:spcAft>
-              <a:defRPr sz="1900">
+              <a:defRPr sz="1650">
                 <a:solidFill>
                   <a:srgbClr val="1B1F23"/>
                 </a:solidFill>
@@ -10076,7 +10236,7 @@
               <a:spcAft>
                 <a:spcPts val="800"/>
               </a:spcAft>
-              <a:defRPr sz="1900">
+              <a:defRPr sz="1650">
                 <a:solidFill>
                   <a:srgbClr val="1B1F23"/>
                 </a:solidFill>
@@ -10092,7 +10252,7 @@
               <a:spcAft>
                 <a:spcPts val="800"/>
               </a:spcAft>
-              <a:defRPr sz="1900">
+              <a:defRPr sz="1650">
                 <a:solidFill>
                   <a:srgbClr val="1B1F23"/>
                 </a:solidFill>
@@ -10108,7 +10268,7 @@
               <a:spcAft>
                 <a:spcPts val="800"/>
               </a:spcAft>
-              <a:defRPr sz="1900">
+              <a:defRPr sz="1650">
                 <a:solidFill>
                   <a:srgbClr val="1B1F23"/>
                 </a:solidFill>
@@ -10121,9 +10281,33 @@
           </a:p>
         </p:txBody>
       </p:sp>
-      <p:sp>
-        <p:nvSpPr>
-          <p:cNvPr id="6" name="TextBox 5"/>
+      <p:pic>
+        <p:nvPicPr>
+          <p:cNvPr id="6" name="Picture 5" descr="evaluation_evidence_chain.png"/>
+          <p:cNvPicPr>
+            <a:picLocks noChangeAspect="1"/>
+          </p:cNvPicPr>
+          <p:nvPr/>
+        </p:nvPicPr>
+        <p:blipFill>
+          <a:blip r:embed="rId2"/>
+          <a:stretch>
+            <a:fillRect/>
+          </a:stretch>
+        </p:blipFill>
+        <p:spPr>
+          <a:xfrm>
+            <a:off x="5394960" y="2654068"/>
+            <a:ext cx="6126480" cy="2418543"/>
+          </a:xfrm>
+          <a:prstGeom prst="rect">
+            <a:avLst/>
+          </a:prstGeom>
+        </p:spPr>
+      </p:pic>
+      <p:sp>
+        <p:nvSpPr>
+          <p:cNvPr id="7" name="TextBox 6"/>
           <p:cNvSpPr txBox="1"/>
           <p:nvPr/>
         </p:nvSpPr>
@@ -10159,7 +10343,7 @@
       </p:sp>
       <p:sp>
         <p:nvSpPr>
-          <p:cNvPr id="7" name="TextBox 6"/>
+          <p:cNvPr id="8" name="TextBox 7"/>
           <p:cNvSpPr txBox="1"/>
           <p:nvPr/>
         </p:nvSpPr>
@@ -10250,7 +10434,7 @@
               </a:defRPr>
             </a:pPr>
             <a:r>
-              <a:t>为什么经典规划器仍会失败？</a:t>
+              <a:t>动态社会导航：局部可行不等于交互可恢复</a:t>
             </a:r>
           </a:p>
         </p:txBody>
@@ -10329,7 +10513,7 @@
               </a:defRPr>
             </a:pPr>
             <a:r>
-              <a:t>局部可行不等于动态交互可恢复</a:t>
+              <a:t>八类场景把几何约束、相互让行与突发遮挡分开检验</a:t>
             </a:r>
           </a:p>
         </p:txBody>
@@ -10368,7 +10552,7 @@
               </a:defRPr>
             </a:pPr>
             <a:r>
-              <a:t>• 对向会车：双方持续占据彼此最优局部轨迹</a:t>
+              <a:t>• 对向会车与双向流：双方局部最优轨迹互相占据</a:t>
             </a:r>
           </a:p>
           <a:p>
@@ -10384,7 +10568,7 @@
               </a:defRPr>
             </a:pPr>
             <a:r>
-              <a:t>• 门口竞争：短时最优控制造成冻结或相互抢占</a:t>
+              <a:t>• 门口与群体封堵：几何瓶颈要求显式退让或绕行</a:t>
             </a:r>
           </a:p>
           <a:p>
@@ -10400,7 +10584,7 @@
               </a:defRPr>
             </a:pPr>
             <a:r>
-              <a:t>• 盲角突现：有限视野下接近速度快速变化</a:t>
+              <a:t>• 交叉流与盲角：有限视野下风险快速进入控制窗口</a:t>
             </a:r>
           </a:p>
           <a:p>
@@ -10416,7 +10600,7 @@
               </a:defRPr>
             </a:pPr>
             <a:r>
-              <a:t>• 临时封堵：局部规划器反复输出无效控制或振荡</a:t>
+              <a:t>• 超车与临时封堵：短时最优可能演化为冻结或振荡</a:t>
             </a:r>
           </a:p>
         </p:txBody>
@@ -10914,7 +11098,7 @@
               </a:defRPr>
             </a:pPr>
             <a:r>
-              <a:t>失败不是单一碰撞标签</a:t>
+              <a:t>DWB 在 Nav2 中负责什么？</a:t>
             </a:r>
           </a:p>
         </p:txBody>
@@ -10993,7 +11177,7 @@
               </a:defRPr>
             </a:pPr>
             <a:r>
-              <a:t>系统区分碰撞风险、冻结、振荡和动态死锁</a:t>
+              <a:t>全局规划给路径，DWB 在局部代价地图上持续选择速度命令</a:t>
             </a:r>
           </a:p>
         </p:txBody>
@@ -11006,104 +11190,112 @@
         </p:nvSpPr>
         <p:spPr>
           <a:xfrm>
-            <a:off x="914400" y="1719072"/>
-            <a:ext cx="10241280" cy="4389120"/>
-          </a:xfrm>
-          <a:prstGeom prst="rect">
-            <a:avLst/>
-          </a:prstGeom>
-          <a:noFill/>
-        </p:spPr>
-        <p:txBody>
-          <a:bodyPr wrap="square">
-            <a:spAutoFit/>
-          </a:bodyPr>
-          <a:lstStyle/>
-          <a:p>
-            <a:pPr>
-              <a:spcAft>
-                <a:spcPts val="800"/>
-              </a:spcAft>
-              <a:defRPr sz="1900">
-                <a:solidFill>
-                  <a:srgbClr val="1B1F23"/>
-                </a:solidFill>
-                <a:latin typeface="Noto Sans CJK SC"/>
-              </a:defRPr>
-            </a:pPr>
-            <a:r>
-              <a:t>• 碰撞风险：前向硬防护或持续闭合趋势</a:t>
-            </a:r>
-          </a:p>
-          <a:p>
-            <a:pPr>
-              <a:spcAft>
-                <a:spcPts val="800"/>
-              </a:spcAft>
-              <a:defRPr sz="1900">
-                <a:solidFill>
-                  <a:srgbClr val="1B1F23"/>
-                </a:solidFill>
-                <a:latin typeface="Noto Sans CJK SC"/>
-              </a:defRPr>
-            </a:pPr>
-            <a:r>
-              <a:t>• 冻结：离目标仍远、位移不足且规划器请求运动</a:t>
-            </a:r>
-          </a:p>
-          <a:p>
-            <a:pPr>
-              <a:spcAft>
-                <a:spcPts val="800"/>
-              </a:spcAft>
-              <a:defRPr sz="1900">
-                <a:solidFill>
-                  <a:srgbClr val="1B1F23"/>
-                </a:solidFill>
-                <a:latin typeface="Noto Sans CJK SC"/>
-              </a:defRPr>
-            </a:pPr>
-            <a:r>
-              <a:t>• 振荡：角速度多次换向但目标进展不足</a:t>
-            </a:r>
-          </a:p>
-          <a:p>
-            <a:pPr>
-              <a:spcAft>
-                <a:spcPts val="800"/>
-              </a:spcAft>
-              <a:defRPr sz="1900">
-                <a:solidFill>
-                  <a:srgbClr val="1B1F23"/>
-                </a:solidFill>
-                <a:latin typeface="Noto Sans CJK SC"/>
-              </a:defRPr>
-            </a:pPr>
-            <a:r>
-              <a:t>• 死锁：持续阻塞且短窗口无法恢复有效进展</a:t>
-            </a:r>
-          </a:p>
-          <a:p>
-            <a:pPr>
-              <a:spcAft>
-                <a:spcPts val="800"/>
-              </a:spcAft>
-              <a:defRPr sz="1900">
-                <a:solidFill>
-                  <a:srgbClr val="1B1F23"/>
-                </a:solidFill>
-                <a:latin typeface="Noto Sans CJK SC"/>
-              </a:defRPr>
-            </a:pPr>
-            <a:r>
-              <a:t>• 最终结局仍独立记录为到达、碰撞、超时或规划失败</a:t>
-            </a:r>
-          </a:p>
-        </p:txBody>
-      </p:sp>
-      <p:sp>
-        <p:nvSpPr>
-          <p:cNvPr id="6" name="TextBox 5"/>
+            <a:off x="685800" y="1691640"/>
+            <a:ext cx="4572000" cy="4389120"/>
+          </a:xfrm>
+          <a:prstGeom prst="rect">
+            <a:avLst/>
+          </a:prstGeom>
+          <a:noFill/>
+        </p:spPr>
+        <p:txBody>
+          <a:bodyPr wrap="square">
+            <a:spAutoFit/>
+          </a:bodyPr>
+          <a:lstStyle/>
+          <a:p>
+            <a:pPr>
+              <a:spcAft>
+                <a:spcPts val="800"/>
+              </a:spcAft>
+              <a:defRPr sz="1650">
+                <a:solidFill>
+                  <a:srgbClr val="1B1F23"/>
+                </a:solidFill>
+                <a:latin typeface="Noto Sans CJK SC"/>
+              </a:defRPr>
+            </a:pPr>
+            <a:r>
+              <a:t>• Planner Server 产生通往 PointGoal 的全局路径</a:t>
+            </a:r>
+          </a:p>
+          <a:p>
+            <a:pPr>
+              <a:spcAft>
+                <a:spcPts val="800"/>
+              </a:spcAft>
+              <a:defRPr sz="1650">
+                <a:solidFill>
+                  <a:srgbClr val="1B1F23"/>
+                </a:solidFill>
+                <a:latin typeface="Noto Sans CJK SC"/>
+              </a:defRPr>
+            </a:pPr>
+            <a:r>
+              <a:t>• Controller Server 调用 DWB 处理局部障碍与轨迹跟踪</a:t>
+            </a:r>
+          </a:p>
+          <a:p>
+            <a:pPr>
+              <a:spcAft>
+                <a:spcPts val="800"/>
+              </a:spcAft>
+              <a:defRPr sz="1650">
+                <a:solidFill>
+                  <a:srgbClr val="1B1F23"/>
+                </a:solidFill>
+                <a:latin typeface="Noto Sans CJK SC"/>
+              </a:defRPr>
+            </a:pPr>
+            <a:r>
+              <a:t>• DWB 输出 cmd_vel；机器人执行后再以新观测滚动重算</a:t>
+            </a:r>
+          </a:p>
+          <a:p>
+            <a:pPr>
+              <a:spcAft>
+                <a:spcPts val="800"/>
+              </a:spcAft>
+              <a:defRPr sz="1650">
+                <a:solidFill>
+                  <a:srgbClr val="1B1F23"/>
+                </a:solidFill>
+                <a:latin typeface="Noto Sans CJK SC"/>
+              </a:defRPr>
+            </a:pPr>
+            <a:r>
+              <a:t>• PGRR 不替换这条控制链，只在失败时临时改变局部目标</a:t>
+            </a:r>
+          </a:p>
+        </p:txBody>
+      </p:sp>
+      <p:pic>
+        <p:nvPicPr>
+          <p:cNvPr id="6" name="Picture 5" descr="dwb_nav2_role.png"/>
+          <p:cNvPicPr>
+            <a:picLocks noChangeAspect="1"/>
+          </p:cNvPicPr>
+          <p:nvPr/>
+        </p:nvPicPr>
+        <p:blipFill>
+          <a:blip r:embed="rId2"/>
+          <a:stretch>
+            <a:fillRect/>
+          </a:stretch>
+        </p:blipFill>
+        <p:spPr>
+          <a:xfrm>
+            <a:off x="5394960" y="2498863"/>
+            <a:ext cx="6126480" cy="2728953"/>
+          </a:xfrm>
+          <a:prstGeom prst="rect">
+            <a:avLst/>
+          </a:prstGeom>
+        </p:spPr>
+      </p:pic>
+      <p:sp>
+        <p:nvSpPr>
+          <p:cNvPr id="7" name="TextBox 6"/>
           <p:cNvSpPr txBox="1"/>
           <p:nvPr/>
         </p:nvSpPr>
@@ -11139,7 +11331,7 @@
       </p:sp>
       <p:sp>
         <p:nvSpPr>
-          <p:cNvPr id="7" name="TextBox 6"/>
+          <p:cNvPr id="8" name="TextBox 7"/>
           <p:cNvSpPr txBox="1"/>
           <p:nvPr/>
         </p:nvSpPr>
@@ -11230,7 +11422,7 @@
               </a:defRPr>
             </a:pPr>
             <a:r>
-              <a:t>研究问题</a:t>
+              <a:t>Dynamic Window：只搜索当前可达的速度</a:t>
             </a:r>
           </a:p>
         </p:txBody>
@@ -11309,7 +11501,7 @@
               </a:defRPr>
             </a:pPr>
             <a:r>
-              <a:t>能否提高困难动态交互的恢复能力，同时不破坏正常规划稳定性？</a:t>
+              <a:t>Dynamic Window 是 DWA 的思想来源；DWB 通过可插拔 generator 产生候选轨迹</a:t>
             </a:r>
           </a:p>
         </p:txBody>
@@ -11322,88 +11514,128 @@
         </p:nvSpPr>
         <p:spPr>
           <a:xfrm>
-            <a:off x="914400" y="1719072"/>
-            <a:ext cx="10241280" cy="4389120"/>
-          </a:xfrm>
-          <a:prstGeom prst="rect">
-            <a:avLst/>
-          </a:prstGeom>
-          <a:noFill/>
-        </p:spPr>
-        <p:txBody>
-          <a:bodyPr wrap="square">
-            <a:spAutoFit/>
-          </a:bodyPr>
-          <a:lstStyle/>
-          <a:p>
-            <a:pPr>
-              <a:spcAft>
-                <a:spcPts val="800"/>
-              </a:spcAft>
-              <a:defRPr sz="1900">
-                <a:solidFill>
-                  <a:srgbClr val="1B1F23"/>
-                </a:solidFill>
-                <a:latin typeface="Noto Sans CJK SC"/>
-              </a:defRPr>
-            </a:pPr>
-            <a:r>
-              <a:t>• 介入应稀疏、可解释、可取消</a:t>
-            </a:r>
-          </a:p>
-          <a:p>
-            <a:pPr>
-              <a:spcAft>
-                <a:spcPts val="800"/>
-              </a:spcAft>
-              <a:defRPr sz="1900">
-                <a:solidFill>
-                  <a:srgbClr val="1B1F23"/>
-                </a:solidFill>
-                <a:latin typeface="Noto Sans CJK SC"/>
-              </a:defRPr>
-            </a:pPr>
-            <a:r>
-              <a:t>• 学习动作必须经过规划可行性约束</a:t>
-            </a:r>
-          </a:p>
-          <a:p>
-            <a:pPr>
-              <a:spcAft>
-                <a:spcPts val="800"/>
-              </a:spcAft>
-              <a:defRPr sz="1900">
-                <a:solidFill>
-                  <a:srgbClr val="1B1F23"/>
-                </a:solidFill>
-                <a:latin typeface="Noto Sans CJK SC"/>
-              </a:defRPr>
-            </a:pPr>
-            <a:r>
-              <a:t>• 训练可用特权监督，测试只能用机器人可观测信息</a:t>
-            </a:r>
-          </a:p>
-          <a:p>
-            <a:pPr>
-              <a:spcAft>
-                <a:spcPts val="800"/>
-              </a:spcAft>
-              <a:defRPr sz="1900">
-                <a:solidFill>
-                  <a:srgbClr val="1B1F23"/>
-                </a:solidFill>
-                <a:latin typeface="Noto Sans CJK SC"/>
-              </a:defRPr>
-            </a:pPr>
-            <a:r>
-              <a:t>• 效果必须在相同 episode manifest 上配对比较</a:t>
-            </a:r>
-          </a:p>
-        </p:txBody>
-      </p:sp>
-      <p:sp>
-        <p:nvSpPr>
-          <p:cNvPr id="6" name="TextBox 5"/>
+            <a:off x="685800" y="1691640"/>
+            <a:ext cx="4572000" cy="4389120"/>
+          </a:xfrm>
+          <a:prstGeom prst="rect">
+            <a:avLst/>
+          </a:prstGeom>
+          <a:noFill/>
+        </p:spPr>
+        <p:txBody>
+          <a:bodyPr wrap="square">
+            <a:spAutoFit/>
+          </a:bodyPr>
+          <a:lstStyle/>
+          <a:p>
+            <a:pPr>
+              <a:spcAft>
+                <a:spcPts val="800"/>
+              </a:spcAft>
+              <a:defRPr sz="1650">
+                <a:solidFill>
+                  <a:srgbClr val="1B1F23"/>
+                </a:solidFill>
+                <a:latin typeface="Noto Sans CJK SC"/>
+              </a:defRPr>
+            </a:pPr>
+            <a:r>
+              <a:t>• DWA 用当前速度、加速度和制动约束构造短时可达窗口</a:t>
+            </a:r>
+          </a:p>
+          <a:p>
+            <a:pPr>
+              <a:spcAft>
+                <a:spcPts val="800"/>
+              </a:spcAft>
+              <a:defRPr sz="1650">
+                <a:solidFill>
+                  <a:srgbClr val="1B1F23"/>
+                </a:solidFill>
+                <a:latin typeface="Noto Sans CJK SC"/>
+              </a:defRPr>
+            </a:pPr>
+            <a:r>
+              <a:t>• DWB 的 trajectory generator 是可插拔接口，具体插件由配置决定</a:t>
+            </a:r>
+          </a:p>
+          <a:p>
+            <a:pPr>
+              <a:spcAft>
+                <a:spcPts val="800"/>
+              </a:spcAft>
+              <a:defRPr sz="1650">
+                <a:solidFill>
+                  <a:srgbClr val="1B1F23"/>
+                </a:solidFill>
+                <a:latin typeface="Noto Sans CJK SC"/>
+              </a:defRPr>
+            </a:pPr>
+            <a:r>
+              <a:t>• generator 对候选控制向前 rollout，形成多条局部轨迹</a:t>
+            </a:r>
+          </a:p>
+          <a:p>
+            <a:pPr>
+              <a:spcAft>
+                <a:spcPts val="800"/>
+              </a:spcAft>
+              <a:defRPr sz="1650">
+                <a:solidFill>
+                  <a:srgbClr val="1B1F23"/>
+                </a:solidFill>
+                <a:latin typeface="Noto Sans CJK SC"/>
+              </a:defRPr>
+            </a:pPr>
+            <a:r>
+              <a:t>• 原始 DWA 要求足够制动距离；DWB 合法性由 generator 与 critics 决定</a:t>
+            </a:r>
+          </a:p>
+          <a:p>
+            <a:pPr>
+              <a:spcAft>
+                <a:spcPts val="800"/>
+              </a:spcAft>
+              <a:defRPr sz="1650">
+                <a:solidFill>
+                  <a:srgbClr val="1B1F23"/>
+                </a:solidFill>
+                <a:latin typeface="Noto Sans CJK SC"/>
+              </a:defRPr>
+            </a:pPr>
+            <a:r>
+              <a:t>• 本图解释 DWA 思想，不断言冻结项目采用特定 generator</a:t>
+            </a:r>
+          </a:p>
+        </p:txBody>
+      </p:sp>
+      <p:pic>
+        <p:nvPicPr>
+          <p:cNvPr id="6" name="Picture 5" descr="dwb_dynamic_window.png"/>
+          <p:cNvPicPr>
+            <a:picLocks noChangeAspect="1"/>
+          </p:cNvPicPr>
+          <p:nvPr/>
+        </p:nvPicPr>
+        <p:blipFill>
+          <a:blip r:embed="rId2"/>
+          <a:stretch>
+            <a:fillRect/>
+          </a:stretch>
+        </p:blipFill>
+        <p:spPr>
+          <a:xfrm>
+            <a:off x="5394960" y="2591399"/>
+            <a:ext cx="6126480" cy="2543880"/>
+          </a:xfrm>
+          <a:prstGeom prst="rect">
+            <a:avLst/>
+          </a:prstGeom>
+        </p:spPr>
+      </p:pic>
+      <p:sp>
+        <p:nvSpPr>
+          <p:cNvPr id="7" name="TextBox 6"/>
           <p:cNvSpPr txBox="1"/>
           <p:nvPr/>
         </p:nvSpPr>
@@ -11439,7 +11671,7 @@
       </p:sp>
       <p:sp>
         <p:nvSpPr>
-          <p:cNvPr id="7" name="TextBox 6"/>
+          <p:cNvPr id="8" name="TextBox 7"/>
           <p:cNvSpPr txBox="1"/>
           <p:nvPr/>
         </p:nvSpPr>
@@ -11530,7 +11762,7 @@
               </a:defRPr>
             </a:pPr>
             <a:r>
-              <a:t>贡献与边界</a:t>
+              <a:t>DWB 如何选出一条轨迹？</a:t>
             </a:r>
           </a:p>
         </p:txBody>
@@ -11609,7 +11841,7 @@
               </a:defRPr>
             </a:pPr>
             <a:r>
-              <a:t>贡献集中在失败触发、规划专家、恢复分布学习和受限重接</a:t>
+              <a:t>多个 critic 对候选轨迹逐项评分，加权总成本最低者成为速度命令</a:t>
             </a:r>
           </a:p>
         </p:txBody>
@@ -11622,104 +11854,128 @@
         </p:nvSpPr>
         <p:spPr>
           <a:xfrm>
-            <a:off x="914400" y="1719072"/>
-            <a:ext cx="10241280" cy="4389120"/>
-          </a:xfrm>
-          <a:prstGeom prst="rect">
-            <a:avLst/>
-          </a:prstGeom>
-          <a:noFill/>
-        </p:spPr>
-        <p:txBody>
-          <a:bodyPr wrap="square">
-            <a:spAutoFit/>
-          </a:bodyPr>
-          <a:lstStyle/>
-          <a:p>
-            <a:pPr>
-              <a:spcAft>
-                <a:spcPts val="800"/>
-              </a:spcAft>
-              <a:defRPr sz="1900">
-                <a:solidFill>
-                  <a:srgbClr val="1B1F23"/>
-                </a:solidFill>
-                <a:latin typeface="Noto Sans CJK SC"/>
-              </a:defRPr>
-            </a:pPr>
-            <a:r>
-              <a:t>• 失败前触发的经典规划器恢复层</a:t>
-            </a:r>
-          </a:p>
-          <a:p>
-            <a:pPr>
-              <a:spcAft>
-                <a:spcPts val="800"/>
-              </a:spcAft>
-              <a:defRPr sz="1900">
-                <a:solidFill>
-                  <a:srgbClr val="1B1F23"/>
-                </a:solidFill>
-                <a:latin typeface="Noto Sans CJK SC"/>
-              </a:defRPr>
-            </a:pPr>
-            <a:r>
-              <a:t>• 特权短时域规划自动生成恢复示范</a:t>
-            </a:r>
-          </a:p>
-          <a:p>
-            <a:pPr>
-              <a:spcAft>
-                <a:spcPts val="800"/>
-              </a:spcAft>
-              <a:defRPr sz="1900">
-                <a:solidFill>
-                  <a:srgbClr val="1B1F23"/>
-                </a:solidFill>
-                <a:latin typeface="Noto Sans CJK SC"/>
-              </a:defRPr>
-            </a:pPr>
-            <a:r>
-              <a:t>• Behavior Cloning + 两轮 DAgger 覆盖策略诱导状态</a:t>
-            </a:r>
-          </a:p>
-          <a:p>
-            <a:pPr>
-              <a:spcAft>
-                <a:spcPts val="800"/>
-              </a:spcAft>
-              <a:defRPr sz="1900">
-                <a:solidFill>
-                  <a:srgbClr val="1B1F23"/>
-                </a:solidFill>
-                <a:latin typeface="Noto Sans CJK SC"/>
-              </a:defRPr>
-            </a:pPr>
-            <a:r>
-              <a:t>• 规划 action mask + 独立安全监督 + 有界状态机</a:t>
-            </a:r>
-          </a:p>
-          <a:p>
-            <a:pPr>
-              <a:spcAft>
-                <a:spcPts val="800"/>
-              </a:spcAft>
-              <a:defRPr sz="1900">
-                <a:solidFill>
-                  <a:srgbClr val="1B1F23"/>
-                </a:solidFill>
-                <a:latin typeface="Noto Sans CJK SC"/>
-              </a:defRPr>
-            </a:pPr>
-            <a:r>
-              <a:t>• PPO、学习 detector、第二 planner、Flatland、硬件与形式安全均非完成声明</a:t>
-            </a:r>
-          </a:p>
-        </p:txBody>
-      </p:sp>
-      <p:sp>
-        <p:nvSpPr>
-          <p:cNvPr id="6" name="TextBox 5"/>
+            <a:off x="685800" y="1691640"/>
+            <a:ext cx="4572000" cy="4389120"/>
+          </a:xfrm>
+          <a:prstGeom prst="rect">
+            <a:avLst/>
+          </a:prstGeom>
+          <a:noFill/>
+        </p:spPr>
+        <p:txBody>
+          <a:bodyPr wrap="square">
+            <a:spAutoFit/>
+          </a:bodyPr>
+          <a:lstStyle/>
+          <a:p>
+            <a:pPr>
+              <a:spcAft>
+                <a:spcPts val="800"/>
+              </a:spcAft>
+              <a:defRPr sz="1650">
+                <a:solidFill>
+                  <a:srgbClr val="1B1F23"/>
+                </a:solidFill>
+                <a:latin typeface="Noto Sans CJK SC"/>
+              </a:defRPr>
+            </a:pPr>
+            <a:r>
+              <a:t>• 障碍相关 critic：检查碰撞与足迹净空</a:t>
+            </a:r>
+          </a:p>
+          <a:p>
+            <a:pPr>
+              <a:spcAft>
+                <a:spcPts val="800"/>
+              </a:spcAft>
+              <a:defRPr sz="1650">
+                <a:solidFill>
+                  <a:srgbClr val="1B1F23"/>
+                </a:solidFill>
+                <a:latin typeface="Noto Sans CJK SC"/>
+              </a:defRPr>
+            </a:pPr>
+            <a:r>
+              <a:t>• 路径相关 critic：约束路径对齐与偏离距离</a:t>
+            </a:r>
+          </a:p>
+          <a:p>
+            <a:pPr>
+              <a:spcAft>
+                <a:spcPts val="800"/>
+              </a:spcAft>
+              <a:defRPr sz="1650">
+                <a:solidFill>
+                  <a:srgbClr val="1B1F23"/>
+                </a:solidFill>
+                <a:latin typeface="Noto Sans CJK SC"/>
+              </a:defRPr>
+            </a:pPr>
+            <a:r>
+              <a:t>• 目标相关 critic：鼓励朝局部目标推进并正确收尾</a:t>
+            </a:r>
+          </a:p>
+          <a:p>
+            <a:pPr>
+              <a:spcAft>
+                <a:spcPts val="800"/>
+              </a:spcAft>
+              <a:defRPr sz="1650">
+                <a:solidFill>
+                  <a:srgbClr val="1B1F23"/>
+                </a:solidFill>
+                <a:latin typeface="Noto Sans CJK SC"/>
+              </a:defRPr>
+            </a:pPr>
+            <a:r>
+              <a:t>• 振荡等 critic：抑制不稳定或反复切换的局部动作</a:t>
+            </a:r>
+          </a:p>
+          <a:p>
+            <a:pPr>
+              <a:spcAft>
+                <a:spcPts val="800"/>
+              </a:spcAft>
+              <a:defRPr sz="1650">
+                <a:solidFill>
+                  <a:srgbClr val="1B1F23"/>
+                </a:solidFill>
+                <a:latin typeface="Noto Sans CJK SC"/>
+              </a:defRPr>
+            </a:pPr>
+            <a:r>
+              <a:t>• 图中是官方 DWB 机制说明，不宣称本项目新增 critic</a:t>
+            </a:r>
+          </a:p>
+        </p:txBody>
+      </p:sp>
+      <p:pic>
+        <p:nvPicPr>
+          <p:cNvPr id="6" name="Picture 5" descr="dwb_critic_scoring.png"/>
+          <p:cNvPicPr>
+            <a:picLocks noChangeAspect="1"/>
+          </p:cNvPicPr>
+          <p:nvPr/>
+        </p:nvPicPr>
+        <p:blipFill>
+          <a:blip r:embed="rId2"/>
+          <a:stretch>
+            <a:fillRect/>
+          </a:stretch>
+        </p:blipFill>
+        <p:spPr>
+          <a:xfrm>
+            <a:off x="5394960" y="2498863"/>
+            <a:ext cx="6126480" cy="2728953"/>
+          </a:xfrm>
+          <a:prstGeom prst="rect">
+            <a:avLst/>
+          </a:prstGeom>
+        </p:spPr>
+      </p:pic>
+      <p:sp>
+        <p:nvSpPr>
+          <p:cNvPr id="7" name="TextBox 6"/>
           <p:cNvSpPr txBox="1"/>
           <p:nvPr/>
         </p:nvSpPr>
@@ -11755,7 +12011,7 @@
       </p:sp>
       <p:sp>
         <p:nvSpPr>
-          <p:cNvPr id="7" name="TextBox 6"/>
+          <p:cNvPr id="8" name="TextBox 7"/>
           <p:cNvSpPr txBox="1"/>
           <p:nvPr/>
         </p:nvSpPr>
@@ -11846,7 +12102,7 @@
               </a:defRPr>
             </a:pPr>
             <a:r>
-              <a:t>总体架构</a:t>
+              <a:t>为什么 DWB 在社会交互中仍可能失败？</a:t>
             </a:r>
           </a:p>
         </p:txBody>
@@ -11925,7 +12181,7 @@
               </a:defRPr>
             </a:pPr>
             <a:r>
-              <a:t>训练侧可用特权规划监督，部署侧严格闭合在 LiDAR 与 Nav2 状态上</a:t>
+              <a:t>局部轨迹最优不包含对方意图，也不保证跨多个滚动窗口主动解套</a:t>
             </a:r>
           </a:p>
         </p:txBody>
@@ -11964,7 +12220,7 @@
               </a:defRPr>
             </a:pPr>
             <a:r>
-              <a:t>• 观测构造 → 失败检测 → 滞回状态机</a:t>
+              <a:t>• 门口会车：两侧都选择前进，安全轨迹集合逐步收缩</a:t>
             </a:r>
           </a:p>
           <a:p>
@@ -11980,7 +12236,7 @@
               </a:defRPr>
             </a:pPr>
             <a:r>
-              <a:t>• 候选动作 → action mask → 恢复策略</a:t>
+              <a:t>• 对向僵持：短窗口内后退代价高，却可能是长期可恢复动作</a:t>
             </a:r>
           </a:p>
           <a:p>
@@ -11996,7 +12252,7 @@
               </a:defRPr>
             </a:pPr>
             <a:r>
-              <a:t>• Goal Mux 保存原目标并发送临时子目标</a:t>
+              <a:t>• 滚动重规划：相邻周期的局部最优可能左右反复切换</a:t>
             </a:r>
           </a:p>
           <a:p>
@@ -12012,14 +12268,14 @@
               </a:defRPr>
             </a:pPr>
             <a:r>
-              <a:t>• DWB 执行动作，重接后恢复常态控制</a:t>
+              <a:t>• 参数调优能改变偏好，但不能提供失败后的显式恢复记忆</a:t>
             </a:r>
           </a:p>
         </p:txBody>
       </p:sp>
       <p:pic>
         <p:nvPicPr>
-          <p:cNvPr id="6" name="Picture 5" descr="system_architecture.png"/>
+          <p:cNvPr id="6" name="Picture 5" descr="dwb_social_failure.png"/>
           <p:cNvPicPr>
             <a:picLocks noChangeAspect="1"/>
           </p:cNvPicPr>
@@ -12033,8 +12289,8 @@
         </p:blipFill>
         <p:spPr>
           <a:xfrm>
-            <a:off x="5394960" y="2458410"/>
-            <a:ext cx="6126480" cy="2809858"/>
+            <a:off x="5394960" y="2693214"/>
+            <a:ext cx="6126480" cy="2340250"/>
           </a:xfrm>
           <a:prstGeom prst="rect">
             <a:avLst/>
@@ -12170,7 +12426,7 @@
               </a:defRPr>
             </a:pPr>
             <a:r>
-              <a:t>正式观测与触发证据</a:t>
+              <a:t>PGRR 放在哪里：失败时接管目标，不接管速度</a:t>
             </a:r>
           </a:p>
         </p:txBody>
@@ -12249,7 +12505,7 @@
               </a:defRPr>
             </a:pPr>
             <a:r>
-              <a:t>部署不使用行人真值、ID 或未来轨迹</a:t>
+              <a:t>正常导航始终由 DWB 控制，恢复层只短时选择临时子目标或离散行为</a:t>
             </a:r>
           </a:p>
         </p:txBody>
@@ -12262,104 +12518,112 @@
         </p:nvSpPr>
         <p:spPr>
           <a:xfrm>
-            <a:off x="914400" y="1719072"/>
-            <a:ext cx="10241280" cy="4389120"/>
-          </a:xfrm>
-          <a:prstGeom prst="rect">
-            <a:avLst/>
-          </a:prstGeom>
-          <a:noFill/>
-        </p:spPr>
-        <p:txBody>
-          <a:bodyPr wrap="square">
-            <a:spAutoFit/>
-          </a:bodyPr>
-          <a:lstStyle/>
-          <a:p>
-            <a:pPr>
-              <a:spcAft>
-                <a:spcPts val="800"/>
-              </a:spcAft>
-              <a:defRPr sz="1900">
-                <a:solidFill>
-                  <a:srgbClr val="1B1F23"/>
-                </a:solidFill>
-                <a:latin typeface="Noto Sans CJK SC"/>
-              </a:defRPr>
-            </a:pPr>
-            <a:r>
-              <a:t>• 最近 5 帧 × 180 beams LiDAR</a:t>
-            </a:r>
-          </a:p>
-          <a:p>
-            <a:pPr>
-              <a:spcAft>
-                <a:spcPts val="800"/>
-              </a:spcAft>
-              <a:defRPr sz="1900">
-                <a:solidFill>
-                  <a:srgbClr val="1B1F23"/>
-                </a:solidFill>
-                <a:latin typeface="Noto Sans CJK SC"/>
-              </a:defRPr>
-            </a:pPr>
-            <a:r>
-              <a:t>• 目标极坐标与前方 8 个局部路径点</a:t>
-            </a:r>
-          </a:p>
-          <a:p>
-            <a:pPr>
-              <a:spcAft>
-                <a:spcPts val="800"/>
-              </a:spcAft>
-              <a:defRPr sz="1900">
-                <a:solidFill>
-                  <a:srgbClr val="1B1F23"/>
-                </a:solidFill>
-                <a:latin typeface="Noto Sans CJK SC"/>
-              </a:defRPr>
-            </a:pPr>
-            <a:r>
-              <a:t>• 机器人速度与 DWB 当前输出</a:t>
-            </a:r>
-          </a:p>
-          <a:p>
-            <a:pPr>
-              <a:spcAft>
-                <a:spcPts val="800"/>
-              </a:spcAft>
-              <a:defRPr sz="1900">
-                <a:solidFill>
-                  <a:srgbClr val="1B1F23"/>
-                </a:solidFill>
-                <a:latin typeface="Noto Sans CJK SC"/>
-              </a:defRPr>
-            </a:pPr>
-            <a:r>
-              <a:t>• 10 步目标进展和角速度历史</a:t>
-            </a:r>
-          </a:p>
-          <a:p>
-            <a:pPr>
-              <a:spcAft>
-                <a:spcPts val="800"/>
-              </a:spcAft>
-              <a:defRPr sz="1900">
-                <a:solidFill>
-                  <a:srgbClr val="1B1F23"/>
-                </a:solidFill>
-                <a:latin typeface="Noto Sans CJK SC"/>
-              </a:defRPr>
-            </a:pPr>
-            <a:r>
-              <a:t>• 规划器状态与规则失败分数</a:t>
-            </a:r>
-          </a:p>
-        </p:txBody>
-      </p:sp>
-      <p:sp>
-        <p:nvSpPr>
-          <p:cNvPr id="6" name="TextBox 5"/>
+            <a:off x="685800" y="1691640"/>
+            <a:ext cx="4572000" cy="4389120"/>
+          </a:xfrm>
+          <a:prstGeom prst="rect">
+            <a:avLst/>
+          </a:prstGeom>
+          <a:noFill/>
+        </p:spPr>
+        <p:txBody>
+          <a:bodyPr wrap="square">
+            <a:spAutoFit/>
+          </a:bodyPr>
+          <a:lstStyle/>
+          <a:p>
+            <a:pPr>
+              <a:spcAft>
+                <a:spcPts val="800"/>
+              </a:spcAft>
+              <a:defRPr sz="1650">
+                <a:solidFill>
+                  <a:srgbClr val="1B1F23"/>
+                </a:solidFill>
+                <a:latin typeface="Noto Sans CJK SC"/>
+              </a:defRPr>
+            </a:pPr>
+            <a:r>
+              <a:t>• 可观测历史 → 规则失败证据 → 滞回状态机</a:t>
+            </a:r>
+          </a:p>
+          <a:p>
+            <a:pPr>
+              <a:spcAft>
+                <a:spcPts val="800"/>
+              </a:spcAft>
+              <a:defRPr sz="1650">
+                <a:solidFill>
+                  <a:srgbClr val="1B1F23"/>
+                </a:solidFill>
+                <a:latin typeface="Noto Sans CJK SC"/>
+              </a:defRPr>
+            </a:pPr>
+            <a:r>
+              <a:t>• 候选恢复动作 → planning mask → 选定策略</a:t>
+            </a:r>
+          </a:p>
+          <a:p>
+            <a:pPr>
+              <a:spcAft>
+                <a:spcPts val="800"/>
+              </a:spcAft>
+              <a:defRPr sz="1650">
+                <a:solidFill>
+                  <a:srgbClr val="1B1F23"/>
+                </a:solidFill>
+                <a:latin typeface="Noto Sans CJK SC"/>
+              </a:defRPr>
+            </a:pPr>
+            <a:r>
+              <a:t>• Goal Mux 保存原始 PointGoal，再发送临时子目标</a:t>
+            </a:r>
+          </a:p>
+          <a:p>
+            <a:pPr>
+              <a:spcAft>
+                <a:spcPts val="800"/>
+              </a:spcAft>
+              <a:defRPr sz="1650">
+                <a:solidFill>
+                  <a:srgbClr val="1B1F23"/>
+                </a:solidFill>
+                <a:latin typeface="Noto Sans CJK SC"/>
+              </a:defRPr>
+            </a:pPr>
+            <a:r>
+              <a:t>• DWB 执行临时目标；确认恢复进展后重接原目标</a:t>
+            </a:r>
+          </a:p>
+        </p:txBody>
+      </p:sp>
+      <p:pic>
+        <p:nvPicPr>
+          <p:cNvPr id="6" name="Picture 5" descr="system_architecture.png"/>
+          <p:cNvPicPr>
+            <a:picLocks noChangeAspect="1"/>
+          </p:cNvPicPr>
+          <p:nvPr/>
+        </p:nvPicPr>
+        <p:blipFill>
+          <a:blip r:embed="rId2"/>
+          <a:stretch>
+            <a:fillRect/>
+          </a:stretch>
+        </p:blipFill>
+        <p:spPr>
+          <a:xfrm>
+            <a:off x="5394960" y="2458410"/>
+            <a:ext cx="6126480" cy="2809858"/>
+          </a:xfrm>
+          <a:prstGeom prst="rect">
+            <a:avLst/>
+          </a:prstGeom>
+        </p:spPr>
+      </p:pic>
+      <p:sp>
+        <p:nvSpPr>
+          <p:cNvPr id="7" name="TextBox 6"/>
           <p:cNvSpPr txBox="1"/>
           <p:nvPr/>
         </p:nvSpPr>
@@ -12395,7 +12659,7 @@
       </p:sp>
       <p:sp>
         <p:nvSpPr>
-          <p:cNvPr id="7" name="TextBox 6"/>
+          <p:cNvPr id="8" name="TextBox 7"/>
           <p:cNvSpPr txBox="1"/>
           <p:nvPr/>
         </p:nvSpPr>
@@ -12486,7 +12750,7 @@
               </a:defRPr>
             </a:pPr>
             <a:r>
-              <a:t>25 个可解释恢复动作</a:t>
+              <a:t>何时触发：多帧失败证据，而不是一次噪声尖峰</a:t>
             </a:r>
           </a:p>
         </p:txBody>
@@ -12565,7 +12829,7 @@
               </a:defRPr>
             </a:pPr>
             <a:r>
-              <a:t>策略做高层选择，不直接输出底盘速度</a:t>
+              <a:t>碰撞风险、冻结、振荡和死锁使用不同证据，并由滞回与 cooldown 合并</a:t>
             </a:r>
           </a:p>
         </p:txBody>
@@ -12604,7 +12868,7 @@
               </a:defRPr>
             </a:pPr>
             <a:r>
-              <a:t>• 21 个临时子目标：3 个半径 × 7 个相对方向</a:t>
+              <a:t>• 碰撞风险：硬防护或持续闭合趋势</a:t>
             </a:r>
           </a:p>
           <a:p>
@@ -12620,7 +12884,7 @@
               </a:defRPr>
             </a:pPr>
             <a:r>
-              <a:t>• 4 个行为：WAIT、BACKUP、REPLAN、CONTINUE</a:t>
+              <a:t>• 冻结：请求运动但目标进展与位移持续不足</a:t>
             </a:r>
           </a:p>
           <a:p>
@@ -12636,7 +12900,7 @@
               </a:defRPr>
             </a:pPr>
             <a:r>
-              <a:t>• 临时目标仍由 DWB 跟踪</a:t>
+              <a:t>• 振荡：角速度多次换向且没有有效推进</a:t>
             </a:r>
           </a:p>
           <a:p>
@@ -12652,14 +12916,30 @@
               </a:defRPr>
             </a:pPr>
             <a:r>
-              <a:t>• 动作 ID 固定，训练、导出和 ROS 推理一致</a:t>
+              <a:t>• 死锁：长期阻塞，经典局部控制无法自行恢复</a:t>
+            </a:r>
+          </a:p>
+          <a:p>
+            <a:pPr>
+              <a:spcAft>
+                <a:spcPts val="800"/>
+              </a:spcAft>
+              <a:defRPr sz="1650">
+                <a:solidFill>
+                  <a:srgbClr val="1B1F23"/>
+                </a:solidFill>
+                <a:latin typeface="Noto Sans CJK SC"/>
+              </a:defRPr>
+            </a:pPr>
+            <a:r>
+              <a:t>• episode 终局仍独立保留，不用 failure score 替代</a:t>
             </a:r>
           </a:p>
         </p:txBody>
       </p:sp>
       <p:pic>
         <p:nvPicPr>
-          <p:cNvPr id="6" name="Picture 5" descr="action_space_expert.png"/>
+          <p:cNvPr id="6" name="Picture 5" descr="dwb_social_failure.png"/>
           <p:cNvPicPr>
             <a:picLocks noChangeAspect="1"/>
           </p:cNvPicPr>
@@ -12673,8 +12953,8 @@
         </p:blipFill>
         <p:spPr>
           <a:xfrm>
-            <a:off x="5394960" y="2331720"/>
-            <a:ext cx="6126480" cy="3063240"/>
+            <a:off x="5394960" y="2693214"/>
+            <a:ext cx="6126480" cy="2340250"/>
           </a:xfrm>
           <a:prstGeom prst="rect">
             <a:avLst/>

</xml_diff>